<commit_message>
Add Iris dataset and related images for lab6
- Added iris.csv containing sepal and petal measurements for Iris species.
- Included cross_val.png for cross-validation visualization.
- Added holdout_model_selection.JPG for model selection illustration.
- Included iris.png for data visualization of the Iris dataset.
</commit_message>
<xml_diff>
--- a/Presentation/Slide.pptx
+++ b/Presentation/Slide.pptx
@@ -39,6 +39,11 @@
     <p:sldId id="284" r:id="rId34"/>
     <p:sldId id="285" r:id="rId35"/>
     <p:sldId id="286" r:id="rId36"/>
+    <p:sldId id="287" r:id="rId37"/>
+    <p:sldId id="288" r:id="rId38"/>
+    <p:sldId id="289" r:id="rId39"/>
+    <p:sldId id="290" r:id="rId40"/>
+    <p:sldId id="291" r:id="rId41"/>
   </p:sldIdLst>
   <p:sldSz cy="5143500" cx="9144000"/>
   <p:notesSz cx="6858000" cy="9144000"/>
@@ -287,7 +292,7 @@
       </p15:sldGuideLst>
     </p:ext>
     <p:ext uri="GoogleSlidesCustomDataVersion2">
-      <go:slidesCustomData xmlns:go="http://customooxmlschemas.google.com/" r:id="rId37" roundtripDataSignature="AMtx7mjHmIBX8puJhbTZjdQgnxeJb9jsLA=="/>
+      <go:slidesCustomData xmlns:go="http://customooxmlschemas.google.com/" r:id="rId42" roundtripDataSignature="AMtx7mgwYIxFcOgxq2LnrIvDNCykrCuRfQ=="/>
     </p:ext>
   </p:extLst>
 </p:presentation>
@@ -1195,7 +1200,7 @@
       </p:grpSpPr>
       <p:sp>
         <p:nvSpPr>
-          <p:cNvPr id="143" name="Google Shape;143;p12:notes"/>
+          <p:cNvPr id="143" name="Google Shape;143;g39a2a7d93f5_0_6:notes"/>
           <p:cNvSpPr txBox="1"/>
           <p:nvPr>
             <p:ph idx="1" type="body"/>
@@ -1234,7 +1239,7 @@
       </p:sp>
       <p:sp>
         <p:nvSpPr>
-          <p:cNvPr id="144" name="Google Shape;144;p12:notes"/>
+          <p:cNvPr id="144" name="Google Shape;144;g39a2a7d93f5_0_6:notes"/>
           <p:cNvSpPr/>
           <p:nvPr>
             <p:ph idx="2" type="sldImg"/>
@@ -1243,7 +1248,7 @@
         <p:spPr>
           <a:xfrm>
             <a:off x="381300" y="685800"/>
-            <a:ext cx="6096075" cy="3429000"/>
+            <a:ext cx="6096000" cy="3429000"/>
           </a:xfrm>
           <a:custGeom>
             <a:rect b="b" l="l" r="r" t="t"/>
@@ -1294,7 +1299,7 @@
       </p:grpSpPr>
       <p:sp>
         <p:nvSpPr>
-          <p:cNvPr id="150" name="Google Shape;150;g3a916ba9e5e_2_18:notes"/>
+          <p:cNvPr id="150" name="Google Shape;150;g3a916ba9e5e_2_6:notes"/>
           <p:cNvSpPr txBox="1"/>
           <p:nvPr>
             <p:ph idx="1" type="body"/>
@@ -1333,7 +1338,7 @@
       </p:sp>
       <p:sp>
         <p:nvSpPr>
-          <p:cNvPr id="151" name="Google Shape;151;g3a916ba9e5e_2_18:notes"/>
+          <p:cNvPr id="151" name="Google Shape;151;g3a916ba9e5e_2_6:notes"/>
           <p:cNvSpPr/>
           <p:nvPr>
             <p:ph idx="2" type="sldImg"/>
@@ -1393,7 +1398,7 @@
       </p:grpSpPr>
       <p:sp>
         <p:nvSpPr>
-          <p:cNvPr id="157" name="Google Shape;157;g3a916ba9e5e_2_6:notes"/>
+          <p:cNvPr id="157" name="Google Shape;157;p12:notes"/>
           <p:cNvSpPr txBox="1"/>
           <p:nvPr>
             <p:ph idx="1" type="body"/>
@@ -1432,7 +1437,7 @@
       </p:sp>
       <p:sp>
         <p:nvSpPr>
-          <p:cNvPr id="158" name="Google Shape;158;g3a916ba9e5e_2_6:notes"/>
+          <p:cNvPr id="158" name="Google Shape;158;p12:notes"/>
           <p:cNvSpPr/>
           <p:nvPr>
             <p:ph idx="2" type="sldImg"/>
@@ -1441,7 +1446,7 @@
         <p:spPr>
           <a:xfrm>
             <a:off x="381300" y="685800"/>
-            <a:ext cx="6096000" cy="3429000"/>
+            <a:ext cx="6096075" cy="3429000"/>
           </a:xfrm>
           <a:custGeom>
             <a:rect b="b" l="l" r="r" t="t"/>
@@ -1492,7 +1497,7 @@
       </p:grpSpPr>
       <p:sp>
         <p:nvSpPr>
-          <p:cNvPr id="164" name="Google Shape;164;p13:notes"/>
+          <p:cNvPr id="164" name="Google Shape;164;g39a2a7d93f5_0_27:notes"/>
           <p:cNvSpPr txBox="1"/>
           <p:nvPr>
             <p:ph idx="1" type="body"/>
@@ -1531,7 +1536,7 @@
       </p:sp>
       <p:sp>
         <p:nvSpPr>
-          <p:cNvPr id="165" name="Google Shape;165;p13:notes"/>
+          <p:cNvPr id="165" name="Google Shape;165;g39a2a7d93f5_0_27:notes"/>
           <p:cNvSpPr/>
           <p:nvPr>
             <p:ph idx="2" type="sldImg"/>
@@ -1540,7 +1545,7 @@
         <p:spPr>
           <a:xfrm>
             <a:off x="381300" y="685800"/>
-            <a:ext cx="6096075" cy="3429000"/>
+            <a:ext cx="6096000" cy="3429000"/>
           </a:xfrm>
           <a:custGeom>
             <a:rect b="b" l="l" r="r" t="t"/>
@@ -1591,7 +1596,7 @@
       </p:grpSpPr>
       <p:sp>
         <p:nvSpPr>
-          <p:cNvPr id="171" name="Google Shape;171;p14:notes"/>
+          <p:cNvPr id="171" name="Google Shape;171;g39a2a7d93f5_0_18:notes"/>
           <p:cNvSpPr txBox="1"/>
           <p:nvPr>
             <p:ph idx="1" type="body"/>
@@ -1630,7 +1635,7 @@
       </p:sp>
       <p:sp>
         <p:nvSpPr>
-          <p:cNvPr id="172" name="Google Shape;172;p14:notes"/>
+          <p:cNvPr id="172" name="Google Shape;172;g39a2a7d93f5_0_18:notes"/>
           <p:cNvSpPr/>
           <p:nvPr>
             <p:ph idx="2" type="sldImg"/>
@@ -1639,7 +1644,7 @@
         <p:spPr>
           <a:xfrm>
             <a:off x="381300" y="685800"/>
-            <a:ext cx="6096075" cy="3429000"/>
+            <a:ext cx="6096000" cy="3429000"/>
           </a:xfrm>
           <a:custGeom>
             <a:rect b="b" l="l" r="r" t="t"/>
@@ -1690,7 +1695,7 @@
       </p:grpSpPr>
       <p:sp>
         <p:nvSpPr>
-          <p:cNvPr id="178" name="Google Shape;178;g3a916ba9e5e_2_12:notes"/>
+          <p:cNvPr id="178" name="Google Shape;178;g3a916ba9e5e_2_18:notes"/>
           <p:cNvSpPr txBox="1"/>
           <p:nvPr>
             <p:ph idx="1" type="body"/>
@@ -1729,7 +1734,7 @@
       </p:sp>
       <p:sp>
         <p:nvSpPr>
-          <p:cNvPr id="179" name="Google Shape;179;g3a916ba9e5e_2_12:notes"/>
+          <p:cNvPr id="179" name="Google Shape;179;g3a916ba9e5e_2_18:notes"/>
           <p:cNvSpPr/>
           <p:nvPr>
             <p:ph idx="2" type="sldImg"/>
@@ -1789,7 +1794,7 @@
       </p:grpSpPr>
       <p:sp>
         <p:nvSpPr>
-          <p:cNvPr id="185" name="Google Shape;185;g3a916ba9e5e_2_54:notes"/>
+          <p:cNvPr id="185" name="Google Shape;185;p13:notes"/>
           <p:cNvSpPr txBox="1"/>
           <p:nvPr>
             <p:ph idx="1" type="body"/>
@@ -1828,7 +1833,7 @@
       </p:sp>
       <p:sp>
         <p:nvSpPr>
-          <p:cNvPr id="186" name="Google Shape;186;g3a916ba9e5e_2_54:notes"/>
+          <p:cNvPr id="186" name="Google Shape;186;p13:notes"/>
           <p:cNvSpPr/>
           <p:nvPr>
             <p:ph idx="2" type="sldImg"/>
@@ -1837,7 +1842,7 @@
         <p:spPr>
           <a:xfrm>
             <a:off x="381300" y="685800"/>
-            <a:ext cx="6096000" cy="3429000"/>
+            <a:ext cx="6096075" cy="3429000"/>
           </a:xfrm>
           <a:custGeom>
             <a:rect b="b" l="l" r="r" t="t"/>
@@ -1888,7 +1893,7 @@
       </p:grpSpPr>
       <p:sp>
         <p:nvSpPr>
-          <p:cNvPr id="192" name="Google Shape;192;p15:notes"/>
+          <p:cNvPr id="192" name="Google Shape;192;p14:notes"/>
           <p:cNvSpPr txBox="1"/>
           <p:nvPr>
             <p:ph idx="1" type="body"/>
@@ -1927,7 +1932,7 @@
       </p:sp>
       <p:sp>
         <p:nvSpPr>
-          <p:cNvPr id="193" name="Google Shape;193;p15:notes"/>
+          <p:cNvPr id="193" name="Google Shape;193;p14:notes"/>
           <p:cNvSpPr/>
           <p:nvPr>
             <p:ph idx="2" type="sldImg"/>
@@ -2104,7 +2109,7 @@
       </p:grpSpPr>
       <p:sp>
         <p:nvSpPr>
-          <p:cNvPr id="199" name="Google Shape;199;p16:notes"/>
+          <p:cNvPr id="199" name="Google Shape;199;g3a916ba9e5e_2_12:notes"/>
           <p:cNvSpPr txBox="1"/>
           <p:nvPr>
             <p:ph idx="1" type="body"/>
@@ -2143,7 +2148,7 @@
       </p:sp>
       <p:sp>
         <p:nvSpPr>
-          <p:cNvPr id="200" name="Google Shape;200;p16:notes"/>
+          <p:cNvPr id="200" name="Google Shape;200;g3a916ba9e5e_2_12:notes"/>
           <p:cNvSpPr/>
           <p:nvPr>
             <p:ph idx="2" type="sldImg"/>
@@ -2152,7 +2157,7 @@
         <p:spPr>
           <a:xfrm>
             <a:off x="381300" y="685800"/>
-            <a:ext cx="6096075" cy="3429000"/>
+            <a:ext cx="6096000" cy="3429000"/>
           </a:xfrm>
           <a:custGeom>
             <a:rect b="b" l="l" r="r" t="t"/>
@@ -2203,7 +2208,7 @@
       </p:grpSpPr>
       <p:sp>
         <p:nvSpPr>
-          <p:cNvPr id="206" name="Google Shape;206;p17:notes"/>
+          <p:cNvPr id="206" name="Google Shape;206;g3a916ba9e5e_2_54:notes"/>
           <p:cNvSpPr txBox="1"/>
           <p:nvPr>
             <p:ph idx="1" type="body"/>
@@ -2242,7 +2247,7 @@
       </p:sp>
       <p:sp>
         <p:nvSpPr>
-          <p:cNvPr id="207" name="Google Shape;207;p17:notes"/>
+          <p:cNvPr id="207" name="Google Shape;207;g3a916ba9e5e_2_54:notes"/>
           <p:cNvSpPr/>
           <p:nvPr>
             <p:ph idx="2" type="sldImg"/>
@@ -2251,7 +2256,7 @@
         <p:spPr>
           <a:xfrm>
             <a:off x="381300" y="685800"/>
-            <a:ext cx="6096075" cy="3429000"/>
+            <a:ext cx="6096000" cy="3429000"/>
           </a:xfrm>
           <a:custGeom>
             <a:rect b="b" l="l" r="r" t="t"/>
@@ -2302,7 +2307,7 @@
       </p:grpSpPr>
       <p:sp>
         <p:nvSpPr>
-          <p:cNvPr id="213" name="Google Shape;213;p18:notes"/>
+          <p:cNvPr id="213" name="Google Shape;213;p15:notes"/>
           <p:cNvSpPr txBox="1"/>
           <p:nvPr>
             <p:ph idx="1" type="body"/>
@@ -2341,7 +2346,7 @@
       </p:sp>
       <p:sp>
         <p:nvSpPr>
-          <p:cNvPr id="214" name="Google Shape;214;p18:notes"/>
+          <p:cNvPr id="214" name="Google Shape;214;p15:notes"/>
           <p:cNvSpPr/>
           <p:nvPr>
             <p:ph idx="2" type="sldImg"/>
@@ -2401,7 +2406,7 @@
       </p:grpSpPr>
       <p:sp>
         <p:nvSpPr>
-          <p:cNvPr id="220" name="Google Shape;220;p19:notes"/>
+          <p:cNvPr id="220" name="Google Shape;220;p16:notes"/>
           <p:cNvSpPr txBox="1"/>
           <p:nvPr>
             <p:ph idx="1" type="body"/>
@@ -2440,7 +2445,7 @@
       </p:sp>
       <p:sp>
         <p:nvSpPr>
-          <p:cNvPr id="221" name="Google Shape;221;p19:notes"/>
+          <p:cNvPr id="221" name="Google Shape;221;p16:notes"/>
           <p:cNvSpPr/>
           <p:nvPr>
             <p:ph idx="2" type="sldImg"/>
@@ -2500,7 +2505,7 @@
       </p:grpSpPr>
       <p:sp>
         <p:nvSpPr>
-          <p:cNvPr id="227" name="Google Shape;227;g3a916ba9e5e_0_23:notes"/>
+          <p:cNvPr id="227" name="Google Shape;227;p17:notes"/>
           <p:cNvSpPr txBox="1"/>
           <p:nvPr>
             <p:ph idx="1" type="body"/>
@@ -2539,7 +2544,7 @@
       </p:sp>
       <p:sp>
         <p:nvSpPr>
-          <p:cNvPr id="228" name="Google Shape;228;g3a916ba9e5e_0_23:notes"/>
+          <p:cNvPr id="228" name="Google Shape;228;p17:notes"/>
           <p:cNvSpPr/>
           <p:nvPr>
             <p:ph idx="2" type="sldImg"/>
@@ -2548,7 +2553,7 @@
         <p:spPr>
           <a:xfrm>
             <a:off x="381300" y="685800"/>
-            <a:ext cx="6096000" cy="3429000"/>
+            <a:ext cx="6096075" cy="3429000"/>
           </a:xfrm>
           <a:custGeom>
             <a:rect b="b" l="l" r="r" t="t"/>
@@ -2585,7 +2590,7 @@
   <p:cSld>
     <p:spTree>
       <p:nvGrpSpPr>
-        <p:cNvPr id="234" name="Shape 234"/>
+        <p:cNvPr id="233" name="Shape 233"/>
         <p:cNvGrpSpPr/>
         <p:nvPr/>
       </p:nvGrpSpPr>
@@ -2599,7 +2604,7 @@
       </p:grpSpPr>
       <p:sp>
         <p:nvSpPr>
-          <p:cNvPr id="235" name="Google Shape;235;p20:notes"/>
+          <p:cNvPr id="234" name="Google Shape;234;g39a2a7d93f5_1_0:notes"/>
           <p:cNvSpPr txBox="1"/>
           <p:nvPr>
             <p:ph idx="1" type="body"/>
@@ -2638,7 +2643,7 @@
       </p:sp>
       <p:sp>
         <p:nvSpPr>
-          <p:cNvPr id="236" name="Google Shape;236;p20:notes"/>
+          <p:cNvPr id="235" name="Google Shape;235;g39a2a7d93f5_1_0:notes"/>
           <p:cNvSpPr/>
           <p:nvPr>
             <p:ph idx="2" type="sldImg"/>
@@ -2647,7 +2652,7 @@
         <p:spPr>
           <a:xfrm>
             <a:off x="381300" y="685800"/>
-            <a:ext cx="6096075" cy="3429000"/>
+            <a:ext cx="6096000" cy="3429000"/>
           </a:xfrm>
           <a:custGeom>
             <a:rect b="b" l="l" r="r" t="t"/>
@@ -2684,7 +2689,7 @@
   <p:cSld>
     <p:spTree>
       <p:nvGrpSpPr>
-        <p:cNvPr id="241" name="Shape 241"/>
+        <p:cNvPr id="240" name="Shape 240"/>
         <p:cNvGrpSpPr/>
         <p:nvPr/>
       </p:nvGrpSpPr>
@@ -2698,7 +2703,7 @@
       </p:grpSpPr>
       <p:sp>
         <p:nvSpPr>
-          <p:cNvPr id="242" name="Google Shape;242;p21:notes"/>
+          <p:cNvPr id="241" name="Google Shape;241;p18:notes"/>
           <p:cNvSpPr txBox="1"/>
           <p:nvPr>
             <p:ph idx="1" type="body"/>
@@ -2737,7 +2742,7 @@
       </p:sp>
       <p:sp>
         <p:nvSpPr>
-          <p:cNvPr id="243" name="Google Shape;243;p21:notes"/>
+          <p:cNvPr id="242" name="Google Shape;242;p18:notes"/>
           <p:cNvSpPr/>
           <p:nvPr>
             <p:ph idx="2" type="sldImg"/>
@@ -2783,7 +2788,7 @@
   <p:cSld>
     <p:spTree>
       <p:nvGrpSpPr>
-        <p:cNvPr id="248" name="Shape 248"/>
+        <p:cNvPr id="247" name="Shape 247"/>
         <p:cNvGrpSpPr/>
         <p:nvPr/>
       </p:nvGrpSpPr>
@@ -2797,7 +2802,7 @@
       </p:grpSpPr>
       <p:sp>
         <p:nvSpPr>
-          <p:cNvPr id="249" name="Google Shape;249;g3a916ba9e5e_0_11:notes"/>
+          <p:cNvPr id="248" name="Google Shape;248;p19:notes"/>
           <p:cNvSpPr txBox="1"/>
           <p:nvPr>
             <p:ph idx="1" type="body"/>
@@ -2836,7 +2841,7 @@
       </p:sp>
       <p:sp>
         <p:nvSpPr>
-          <p:cNvPr id="250" name="Google Shape;250;g3a916ba9e5e_0_11:notes"/>
+          <p:cNvPr id="249" name="Google Shape;249;p19:notes"/>
           <p:cNvSpPr/>
           <p:nvPr>
             <p:ph idx="2" type="sldImg"/>
@@ -2845,7 +2850,7 @@
         <p:spPr>
           <a:xfrm>
             <a:off x="381300" y="685800"/>
-            <a:ext cx="6096000" cy="3429000"/>
+            <a:ext cx="6096075" cy="3429000"/>
           </a:xfrm>
           <a:custGeom>
             <a:rect b="b" l="l" r="r" t="t"/>
@@ -2882,7 +2887,7 @@
   <p:cSld>
     <p:spTree>
       <p:nvGrpSpPr>
-        <p:cNvPr id="255" name="Shape 255"/>
+        <p:cNvPr id="254" name="Shape 254"/>
         <p:cNvGrpSpPr/>
         <p:nvPr/>
       </p:nvGrpSpPr>
@@ -2896,7 +2901,7 @@
       </p:grpSpPr>
       <p:sp>
         <p:nvSpPr>
-          <p:cNvPr id="256" name="Google Shape;256;g3a916ba9e5e_0_17:notes"/>
+          <p:cNvPr id="255" name="Google Shape;255;g3a916ba9e5e_0_23:notes"/>
           <p:cNvSpPr txBox="1"/>
           <p:nvPr>
             <p:ph idx="1" type="body"/>
@@ -2935,7 +2940,7 @@
       </p:sp>
       <p:sp>
         <p:nvSpPr>
-          <p:cNvPr id="257" name="Google Shape;257;g3a916ba9e5e_0_17:notes"/>
+          <p:cNvPr id="256" name="Google Shape;256;g3a916ba9e5e_0_23:notes"/>
           <p:cNvSpPr/>
           <p:nvPr>
             <p:ph idx="2" type="sldImg"/>
@@ -2995,7 +3000,7 @@
       </p:grpSpPr>
       <p:sp>
         <p:nvSpPr>
-          <p:cNvPr id="263" name="Google Shape;263;p22:notes"/>
+          <p:cNvPr id="263" name="Google Shape;263;p20:notes"/>
           <p:cNvSpPr txBox="1"/>
           <p:nvPr>
             <p:ph idx="1" type="body"/>
@@ -3034,7 +3039,7 @@
       </p:sp>
       <p:sp>
         <p:nvSpPr>
-          <p:cNvPr id="264" name="Google Shape;264;p22:notes"/>
+          <p:cNvPr id="264" name="Google Shape;264;p20:notes"/>
           <p:cNvSpPr/>
           <p:nvPr>
             <p:ph idx="2" type="sldImg"/>
@@ -3193,7 +3198,7 @@
       </p:grpSpPr>
       <p:sp>
         <p:nvSpPr>
-          <p:cNvPr id="270" name="Google Shape;270;p23:notes"/>
+          <p:cNvPr id="270" name="Google Shape;270;g3abaf853488_0_0:notes"/>
           <p:cNvSpPr txBox="1"/>
           <p:nvPr>
             <p:ph idx="1" type="body"/>
@@ -3232,7 +3237,7 @@
       </p:sp>
       <p:sp>
         <p:nvSpPr>
-          <p:cNvPr id="271" name="Google Shape;271;p23:notes"/>
+          <p:cNvPr id="271" name="Google Shape;271;g3abaf853488_0_0:notes"/>
           <p:cNvSpPr/>
           <p:nvPr>
             <p:ph idx="2" type="sldImg"/>
@@ -3241,7 +3246,7 @@
         <p:spPr>
           <a:xfrm>
             <a:off x="381300" y="685800"/>
-            <a:ext cx="6096075" cy="3429000"/>
+            <a:ext cx="6096000" cy="3429000"/>
           </a:xfrm>
           <a:custGeom>
             <a:rect b="b" l="l" r="r" t="t"/>
@@ -3292,7 +3297,7 @@
       </p:grpSpPr>
       <p:sp>
         <p:nvSpPr>
-          <p:cNvPr id="277" name="Google Shape;277;p24:notes"/>
+          <p:cNvPr id="277" name="Google Shape;277;p21:notes"/>
           <p:cNvSpPr txBox="1"/>
           <p:nvPr>
             <p:ph idx="1" type="body"/>
@@ -3331,7 +3336,502 @@
       </p:sp>
       <p:sp>
         <p:nvSpPr>
-          <p:cNvPr id="278" name="Google Shape;278;p24:notes"/>
+          <p:cNvPr id="278" name="Google Shape;278;p21:notes"/>
+          <p:cNvSpPr/>
+          <p:nvPr>
+            <p:ph idx="2" type="sldImg"/>
+          </p:nvPr>
+        </p:nvSpPr>
+        <p:spPr>
+          <a:xfrm>
+            <a:off x="381300" y="685800"/>
+            <a:ext cx="6096075" cy="3429000"/>
+          </a:xfrm>
+          <a:custGeom>
+            <a:rect b="b" l="l" r="r" t="t"/>
+            <a:pathLst>
+              <a:path extrusionOk="0" h="120000" w="120000">
+                <a:moveTo>
+                  <a:pt x="0" y="0"/>
+                </a:moveTo>
+                <a:lnTo>
+                  <a:pt x="120000" y="0"/>
+                </a:lnTo>
+                <a:lnTo>
+                  <a:pt x="120000" y="120000"/>
+                </a:lnTo>
+                <a:lnTo>
+                  <a:pt x="0" y="120000"/>
+                </a:lnTo>
+                <a:close/>
+              </a:path>
+            </a:pathLst>
+          </a:custGeom>
+        </p:spPr>
+      </p:sp>
+    </p:spTree>
+  </p:cSld>
+  <p:clrMapOvr>
+    <a:masterClrMapping/>
+  </p:clrMapOvr>
+</p:notes>
+</file>
+
+<file path=ppt/notesSlides/notesSlide32.xml><?xml version="1.0" encoding="utf-8"?>
+<p:notes xmlns:a="http://schemas.openxmlformats.org/drawingml/2006/main" xmlns:r="http://schemas.openxmlformats.org/officeDocument/2006/relationships" xmlns:mc="http://schemas.openxmlformats.org/markup-compatibility/2006" xmlns:mv="urn:schemas-microsoft-com:mac:vml" xmlns:p="http://schemas.openxmlformats.org/presentationml/2006/main" xmlns:c="http://schemas.openxmlformats.org/drawingml/2006/chart" xmlns:dgm="http://schemas.openxmlformats.org/drawingml/2006/diagram" xmlns:o="urn:schemas-microsoft-com:office:office" xmlns:v="urn:schemas-microsoft-com:vml" xmlns:pvml="urn:schemas-microsoft-com:office:powerpoint" xmlns:com="http://schemas.openxmlformats.org/drawingml/2006/compatibility" xmlns:p14="http://schemas.microsoft.com/office/powerpoint/2010/main" xmlns:p15="http://schemas.microsoft.com/office/powerpoint/2012/main" xmlns:ahyp="http://schemas.microsoft.com/office/drawing/2018/hyperlinkcolor" showMasterPhAnim="0" showMasterSp="0">
+  <p:cSld>
+    <p:spTree>
+      <p:nvGrpSpPr>
+        <p:cNvPr id="283" name="Shape 283"/>
+        <p:cNvGrpSpPr/>
+        <p:nvPr/>
+      </p:nvGrpSpPr>
+      <p:grpSpPr>
+        <a:xfrm>
+          <a:off x="0" y="0"/>
+          <a:ext cx="0" cy="0"/>
+          <a:chOff x="0" y="0"/>
+          <a:chExt cx="0" cy="0"/>
+        </a:xfrm>
+      </p:grpSpPr>
+      <p:sp>
+        <p:nvSpPr>
+          <p:cNvPr id="284" name="Google Shape;284;g3a916ba9e5e_0_11:notes"/>
+          <p:cNvSpPr txBox="1"/>
+          <p:nvPr>
+            <p:ph idx="1" type="body"/>
+          </p:nvPr>
+        </p:nvSpPr>
+        <p:spPr>
+          <a:xfrm>
+            <a:off x="685800" y="4343400"/>
+            <a:ext cx="5486400" cy="4114800"/>
+          </a:xfrm>
+          <a:prstGeom prst="rect">
+            <a:avLst/>
+          </a:prstGeom>
+        </p:spPr>
+        <p:txBody>
+          <a:bodyPr anchorCtr="0" anchor="t" bIns="91425" lIns="91425" spcFirstLastPara="1" rIns="91425" wrap="square" tIns="91425">
+            <a:noAutofit/>
+          </a:bodyPr>
+          <a:lstStyle/>
+          <a:p>
+            <a:pPr indent="0" lvl="0" marL="0" rtl="0" algn="l">
+              <a:spcBef>
+                <a:spcPts val="0"/>
+              </a:spcBef>
+              <a:spcAft>
+                <a:spcPts val="0"/>
+              </a:spcAft>
+              <a:buNone/>
+            </a:pPr>
+            <a:r>
+              <a:t/>
+            </a:r>
+            <a:endParaRPr/>
+          </a:p>
+        </p:txBody>
+      </p:sp>
+      <p:sp>
+        <p:nvSpPr>
+          <p:cNvPr id="285" name="Google Shape;285;g3a916ba9e5e_0_11:notes"/>
+          <p:cNvSpPr/>
+          <p:nvPr>
+            <p:ph idx="2" type="sldImg"/>
+          </p:nvPr>
+        </p:nvSpPr>
+        <p:spPr>
+          <a:xfrm>
+            <a:off x="381300" y="685800"/>
+            <a:ext cx="6096000" cy="3429000"/>
+          </a:xfrm>
+          <a:custGeom>
+            <a:rect b="b" l="l" r="r" t="t"/>
+            <a:pathLst>
+              <a:path extrusionOk="0" h="120000" w="120000">
+                <a:moveTo>
+                  <a:pt x="0" y="0"/>
+                </a:moveTo>
+                <a:lnTo>
+                  <a:pt x="120000" y="0"/>
+                </a:lnTo>
+                <a:lnTo>
+                  <a:pt x="120000" y="120000"/>
+                </a:lnTo>
+                <a:lnTo>
+                  <a:pt x="0" y="120000"/>
+                </a:lnTo>
+                <a:close/>
+              </a:path>
+            </a:pathLst>
+          </a:custGeom>
+        </p:spPr>
+      </p:sp>
+    </p:spTree>
+  </p:cSld>
+  <p:clrMapOvr>
+    <a:masterClrMapping/>
+  </p:clrMapOvr>
+</p:notes>
+</file>
+
+<file path=ppt/notesSlides/notesSlide33.xml><?xml version="1.0" encoding="utf-8"?>
+<p:notes xmlns:a="http://schemas.openxmlformats.org/drawingml/2006/main" xmlns:r="http://schemas.openxmlformats.org/officeDocument/2006/relationships" xmlns:mc="http://schemas.openxmlformats.org/markup-compatibility/2006" xmlns:mv="urn:schemas-microsoft-com:mac:vml" xmlns:p="http://schemas.openxmlformats.org/presentationml/2006/main" xmlns:c="http://schemas.openxmlformats.org/drawingml/2006/chart" xmlns:dgm="http://schemas.openxmlformats.org/drawingml/2006/diagram" xmlns:o="urn:schemas-microsoft-com:office:office" xmlns:v="urn:schemas-microsoft-com:vml" xmlns:pvml="urn:schemas-microsoft-com:office:powerpoint" xmlns:com="http://schemas.openxmlformats.org/drawingml/2006/compatibility" xmlns:p14="http://schemas.microsoft.com/office/powerpoint/2010/main" xmlns:p15="http://schemas.microsoft.com/office/powerpoint/2012/main" xmlns:ahyp="http://schemas.microsoft.com/office/drawing/2018/hyperlinkcolor" showMasterPhAnim="0" showMasterSp="0">
+  <p:cSld>
+    <p:spTree>
+      <p:nvGrpSpPr>
+        <p:cNvPr id="290" name="Shape 290"/>
+        <p:cNvGrpSpPr/>
+        <p:nvPr/>
+      </p:nvGrpSpPr>
+      <p:grpSpPr>
+        <a:xfrm>
+          <a:off x="0" y="0"/>
+          <a:ext cx="0" cy="0"/>
+          <a:chOff x="0" y="0"/>
+          <a:chExt cx="0" cy="0"/>
+        </a:xfrm>
+      </p:grpSpPr>
+      <p:sp>
+        <p:nvSpPr>
+          <p:cNvPr id="291" name="Google Shape;291;g3a916ba9e5e_0_17:notes"/>
+          <p:cNvSpPr txBox="1"/>
+          <p:nvPr>
+            <p:ph idx="1" type="body"/>
+          </p:nvPr>
+        </p:nvSpPr>
+        <p:spPr>
+          <a:xfrm>
+            <a:off x="685800" y="4343400"/>
+            <a:ext cx="5486400" cy="4114800"/>
+          </a:xfrm>
+          <a:prstGeom prst="rect">
+            <a:avLst/>
+          </a:prstGeom>
+        </p:spPr>
+        <p:txBody>
+          <a:bodyPr anchorCtr="0" anchor="t" bIns="91425" lIns="91425" spcFirstLastPara="1" rIns="91425" wrap="square" tIns="91425">
+            <a:noAutofit/>
+          </a:bodyPr>
+          <a:lstStyle/>
+          <a:p>
+            <a:pPr indent="0" lvl="0" marL="0" rtl="0" algn="l">
+              <a:spcBef>
+                <a:spcPts val="0"/>
+              </a:spcBef>
+              <a:spcAft>
+                <a:spcPts val="0"/>
+              </a:spcAft>
+              <a:buNone/>
+            </a:pPr>
+            <a:r>
+              <a:t/>
+            </a:r>
+            <a:endParaRPr/>
+          </a:p>
+        </p:txBody>
+      </p:sp>
+      <p:sp>
+        <p:nvSpPr>
+          <p:cNvPr id="292" name="Google Shape;292;g3a916ba9e5e_0_17:notes"/>
+          <p:cNvSpPr/>
+          <p:nvPr>
+            <p:ph idx="2" type="sldImg"/>
+          </p:nvPr>
+        </p:nvSpPr>
+        <p:spPr>
+          <a:xfrm>
+            <a:off x="381300" y="685800"/>
+            <a:ext cx="6096000" cy="3429000"/>
+          </a:xfrm>
+          <a:custGeom>
+            <a:rect b="b" l="l" r="r" t="t"/>
+            <a:pathLst>
+              <a:path extrusionOk="0" h="120000" w="120000">
+                <a:moveTo>
+                  <a:pt x="0" y="0"/>
+                </a:moveTo>
+                <a:lnTo>
+                  <a:pt x="120000" y="0"/>
+                </a:lnTo>
+                <a:lnTo>
+                  <a:pt x="120000" y="120000"/>
+                </a:lnTo>
+                <a:lnTo>
+                  <a:pt x="0" y="120000"/>
+                </a:lnTo>
+                <a:close/>
+              </a:path>
+            </a:pathLst>
+          </a:custGeom>
+        </p:spPr>
+      </p:sp>
+    </p:spTree>
+  </p:cSld>
+  <p:clrMapOvr>
+    <a:masterClrMapping/>
+  </p:clrMapOvr>
+</p:notes>
+</file>
+
+<file path=ppt/notesSlides/notesSlide34.xml><?xml version="1.0" encoding="utf-8"?>
+<p:notes xmlns:a="http://schemas.openxmlformats.org/drawingml/2006/main" xmlns:r="http://schemas.openxmlformats.org/officeDocument/2006/relationships" xmlns:mc="http://schemas.openxmlformats.org/markup-compatibility/2006" xmlns:mv="urn:schemas-microsoft-com:mac:vml" xmlns:p="http://schemas.openxmlformats.org/presentationml/2006/main" xmlns:c="http://schemas.openxmlformats.org/drawingml/2006/chart" xmlns:dgm="http://schemas.openxmlformats.org/drawingml/2006/diagram" xmlns:o="urn:schemas-microsoft-com:office:office" xmlns:v="urn:schemas-microsoft-com:vml" xmlns:pvml="urn:schemas-microsoft-com:office:powerpoint" xmlns:com="http://schemas.openxmlformats.org/drawingml/2006/compatibility" xmlns:p14="http://schemas.microsoft.com/office/powerpoint/2010/main" xmlns:p15="http://schemas.microsoft.com/office/powerpoint/2012/main" xmlns:ahyp="http://schemas.microsoft.com/office/drawing/2018/hyperlinkcolor" showMasterPhAnim="0" showMasterSp="0">
+  <p:cSld>
+    <p:spTree>
+      <p:nvGrpSpPr>
+        <p:cNvPr id="297" name="Shape 297"/>
+        <p:cNvGrpSpPr/>
+        <p:nvPr/>
+      </p:nvGrpSpPr>
+      <p:grpSpPr>
+        <a:xfrm>
+          <a:off x="0" y="0"/>
+          <a:ext cx="0" cy="0"/>
+          <a:chOff x="0" y="0"/>
+          <a:chExt cx="0" cy="0"/>
+        </a:xfrm>
+      </p:grpSpPr>
+      <p:sp>
+        <p:nvSpPr>
+          <p:cNvPr id="298" name="Google Shape;298;p22:notes"/>
+          <p:cNvSpPr txBox="1"/>
+          <p:nvPr>
+            <p:ph idx="1" type="body"/>
+          </p:nvPr>
+        </p:nvSpPr>
+        <p:spPr>
+          <a:xfrm>
+            <a:off x="685800" y="4343400"/>
+            <a:ext cx="5486400" cy="4114800"/>
+          </a:xfrm>
+          <a:prstGeom prst="rect">
+            <a:avLst/>
+          </a:prstGeom>
+        </p:spPr>
+        <p:txBody>
+          <a:bodyPr anchorCtr="0" anchor="t" bIns="91425" lIns="91425" spcFirstLastPara="1" rIns="91425" wrap="square" tIns="91425">
+            <a:noAutofit/>
+          </a:bodyPr>
+          <a:lstStyle/>
+          <a:p>
+            <a:pPr indent="0" lvl="0" marL="0" rtl="0" algn="l">
+              <a:spcBef>
+                <a:spcPts val="0"/>
+              </a:spcBef>
+              <a:spcAft>
+                <a:spcPts val="0"/>
+              </a:spcAft>
+              <a:buNone/>
+            </a:pPr>
+            <a:r>
+              <a:t/>
+            </a:r>
+            <a:endParaRPr/>
+          </a:p>
+        </p:txBody>
+      </p:sp>
+      <p:sp>
+        <p:nvSpPr>
+          <p:cNvPr id="299" name="Google Shape;299;p22:notes"/>
+          <p:cNvSpPr/>
+          <p:nvPr>
+            <p:ph idx="2" type="sldImg"/>
+          </p:nvPr>
+        </p:nvSpPr>
+        <p:spPr>
+          <a:xfrm>
+            <a:off x="381300" y="685800"/>
+            <a:ext cx="6096075" cy="3429000"/>
+          </a:xfrm>
+          <a:custGeom>
+            <a:rect b="b" l="l" r="r" t="t"/>
+            <a:pathLst>
+              <a:path extrusionOk="0" h="120000" w="120000">
+                <a:moveTo>
+                  <a:pt x="0" y="0"/>
+                </a:moveTo>
+                <a:lnTo>
+                  <a:pt x="120000" y="0"/>
+                </a:lnTo>
+                <a:lnTo>
+                  <a:pt x="120000" y="120000"/>
+                </a:lnTo>
+                <a:lnTo>
+                  <a:pt x="0" y="120000"/>
+                </a:lnTo>
+                <a:close/>
+              </a:path>
+            </a:pathLst>
+          </a:custGeom>
+        </p:spPr>
+      </p:sp>
+    </p:spTree>
+  </p:cSld>
+  <p:clrMapOvr>
+    <a:masterClrMapping/>
+  </p:clrMapOvr>
+</p:notes>
+</file>
+
+<file path=ppt/notesSlides/notesSlide35.xml><?xml version="1.0" encoding="utf-8"?>
+<p:notes xmlns:a="http://schemas.openxmlformats.org/drawingml/2006/main" xmlns:r="http://schemas.openxmlformats.org/officeDocument/2006/relationships" xmlns:mc="http://schemas.openxmlformats.org/markup-compatibility/2006" xmlns:mv="urn:schemas-microsoft-com:mac:vml" xmlns:p="http://schemas.openxmlformats.org/presentationml/2006/main" xmlns:c="http://schemas.openxmlformats.org/drawingml/2006/chart" xmlns:dgm="http://schemas.openxmlformats.org/drawingml/2006/diagram" xmlns:o="urn:schemas-microsoft-com:office:office" xmlns:v="urn:schemas-microsoft-com:vml" xmlns:pvml="urn:schemas-microsoft-com:office:powerpoint" xmlns:com="http://schemas.openxmlformats.org/drawingml/2006/compatibility" xmlns:p14="http://schemas.microsoft.com/office/powerpoint/2010/main" xmlns:p15="http://schemas.microsoft.com/office/powerpoint/2012/main" xmlns:ahyp="http://schemas.microsoft.com/office/drawing/2018/hyperlinkcolor" showMasterPhAnim="0" showMasterSp="0">
+  <p:cSld>
+    <p:spTree>
+      <p:nvGrpSpPr>
+        <p:cNvPr id="304" name="Shape 304"/>
+        <p:cNvGrpSpPr/>
+        <p:nvPr/>
+      </p:nvGrpSpPr>
+      <p:grpSpPr>
+        <a:xfrm>
+          <a:off x="0" y="0"/>
+          <a:ext cx="0" cy="0"/>
+          <a:chOff x="0" y="0"/>
+          <a:chExt cx="0" cy="0"/>
+        </a:xfrm>
+      </p:grpSpPr>
+      <p:sp>
+        <p:nvSpPr>
+          <p:cNvPr id="305" name="Google Shape;305;p23:notes"/>
+          <p:cNvSpPr txBox="1"/>
+          <p:nvPr>
+            <p:ph idx="1" type="body"/>
+          </p:nvPr>
+        </p:nvSpPr>
+        <p:spPr>
+          <a:xfrm>
+            <a:off x="685800" y="4343400"/>
+            <a:ext cx="5486400" cy="4114800"/>
+          </a:xfrm>
+          <a:prstGeom prst="rect">
+            <a:avLst/>
+          </a:prstGeom>
+        </p:spPr>
+        <p:txBody>
+          <a:bodyPr anchorCtr="0" anchor="t" bIns="91425" lIns="91425" spcFirstLastPara="1" rIns="91425" wrap="square" tIns="91425">
+            <a:noAutofit/>
+          </a:bodyPr>
+          <a:lstStyle/>
+          <a:p>
+            <a:pPr indent="0" lvl="0" marL="0" rtl="0" algn="l">
+              <a:spcBef>
+                <a:spcPts val="0"/>
+              </a:spcBef>
+              <a:spcAft>
+                <a:spcPts val="0"/>
+              </a:spcAft>
+              <a:buNone/>
+            </a:pPr>
+            <a:r>
+              <a:t/>
+            </a:r>
+            <a:endParaRPr/>
+          </a:p>
+        </p:txBody>
+      </p:sp>
+      <p:sp>
+        <p:nvSpPr>
+          <p:cNvPr id="306" name="Google Shape;306;p23:notes"/>
+          <p:cNvSpPr/>
+          <p:nvPr>
+            <p:ph idx="2" type="sldImg"/>
+          </p:nvPr>
+        </p:nvSpPr>
+        <p:spPr>
+          <a:xfrm>
+            <a:off x="381300" y="685800"/>
+            <a:ext cx="6096075" cy="3429000"/>
+          </a:xfrm>
+          <a:custGeom>
+            <a:rect b="b" l="l" r="r" t="t"/>
+            <a:pathLst>
+              <a:path extrusionOk="0" h="120000" w="120000">
+                <a:moveTo>
+                  <a:pt x="0" y="0"/>
+                </a:moveTo>
+                <a:lnTo>
+                  <a:pt x="120000" y="0"/>
+                </a:lnTo>
+                <a:lnTo>
+                  <a:pt x="120000" y="120000"/>
+                </a:lnTo>
+                <a:lnTo>
+                  <a:pt x="0" y="120000"/>
+                </a:lnTo>
+                <a:close/>
+              </a:path>
+            </a:pathLst>
+          </a:custGeom>
+        </p:spPr>
+      </p:sp>
+    </p:spTree>
+  </p:cSld>
+  <p:clrMapOvr>
+    <a:masterClrMapping/>
+  </p:clrMapOvr>
+</p:notes>
+</file>
+
+<file path=ppt/notesSlides/notesSlide36.xml><?xml version="1.0" encoding="utf-8"?>
+<p:notes xmlns:a="http://schemas.openxmlformats.org/drawingml/2006/main" xmlns:r="http://schemas.openxmlformats.org/officeDocument/2006/relationships" xmlns:mc="http://schemas.openxmlformats.org/markup-compatibility/2006" xmlns:mv="urn:schemas-microsoft-com:mac:vml" xmlns:p="http://schemas.openxmlformats.org/presentationml/2006/main" xmlns:c="http://schemas.openxmlformats.org/drawingml/2006/chart" xmlns:dgm="http://schemas.openxmlformats.org/drawingml/2006/diagram" xmlns:o="urn:schemas-microsoft-com:office:office" xmlns:v="urn:schemas-microsoft-com:vml" xmlns:pvml="urn:schemas-microsoft-com:office:powerpoint" xmlns:com="http://schemas.openxmlformats.org/drawingml/2006/compatibility" xmlns:p14="http://schemas.microsoft.com/office/powerpoint/2010/main" xmlns:p15="http://schemas.microsoft.com/office/powerpoint/2012/main" xmlns:ahyp="http://schemas.microsoft.com/office/drawing/2018/hyperlinkcolor" showMasterPhAnim="0" showMasterSp="0">
+  <p:cSld>
+    <p:spTree>
+      <p:nvGrpSpPr>
+        <p:cNvPr id="311" name="Shape 311"/>
+        <p:cNvGrpSpPr/>
+        <p:nvPr/>
+      </p:nvGrpSpPr>
+      <p:grpSpPr>
+        <a:xfrm>
+          <a:off x="0" y="0"/>
+          <a:ext cx="0" cy="0"/>
+          <a:chOff x="0" y="0"/>
+          <a:chExt cx="0" cy="0"/>
+        </a:xfrm>
+      </p:grpSpPr>
+      <p:sp>
+        <p:nvSpPr>
+          <p:cNvPr id="312" name="Google Shape;312;p24:notes"/>
+          <p:cNvSpPr txBox="1"/>
+          <p:nvPr>
+            <p:ph idx="1" type="body"/>
+          </p:nvPr>
+        </p:nvSpPr>
+        <p:spPr>
+          <a:xfrm>
+            <a:off x="685800" y="4343400"/>
+            <a:ext cx="5486400" cy="4114800"/>
+          </a:xfrm>
+          <a:prstGeom prst="rect">
+            <a:avLst/>
+          </a:prstGeom>
+        </p:spPr>
+        <p:txBody>
+          <a:bodyPr anchorCtr="0" anchor="t" bIns="91425" lIns="91425" spcFirstLastPara="1" rIns="91425" wrap="square" tIns="91425">
+            <a:noAutofit/>
+          </a:bodyPr>
+          <a:lstStyle/>
+          <a:p>
+            <a:pPr indent="0" lvl="0" marL="0" rtl="0" algn="l">
+              <a:spcBef>
+                <a:spcPts val="0"/>
+              </a:spcBef>
+              <a:spcAft>
+                <a:spcPts val="0"/>
+              </a:spcAft>
+              <a:buNone/>
+            </a:pPr>
+            <a:r>
+              <a:t/>
+            </a:r>
+            <a:endParaRPr/>
+          </a:p>
+        </p:txBody>
+      </p:sp>
+      <p:sp>
+        <p:nvSpPr>
+          <p:cNvPr id="313" name="Google Shape;313;p24:notes"/>
           <p:cNvSpPr/>
           <p:nvPr>
             <p:ph idx="2" type="sldImg"/>
@@ -12201,7 +12701,7 @@
       </p:grpSpPr>
       <p:sp>
         <p:nvSpPr>
-          <p:cNvPr id="146" name="Google Shape;146;p12"/>
+          <p:cNvPr id="146" name="Google Shape;146;g39a2a7d93f5_0_6"/>
           <p:cNvSpPr txBox="1"/>
           <p:nvPr>
             <p:ph type="title"/>
@@ -12247,23 +12747,18 @@
           </a:p>
         </p:txBody>
       </p:sp>
-      <p:pic>
-        <p:nvPicPr>
-          <p:cNvPr id="147" name="Google Shape;147;p12"/>
-          <p:cNvPicPr preferRelativeResize="0"/>
-          <p:nvPr/>
-        </p:nvPicPr>
-        <p:blipFill rotWithShape="1">
-          <a:blip r:embed="rId3">
-            <a:alphaModFix/>
-          </a:blip>
-          <a:srcRect b="0" l="0" r="0" t="0"/>
-          <a:stretch/>
-        </p:blipFill>
-        <p:spPr>
-          <a:xfrm>
-            <a:off x="740264" y="1056256"/>
-            <a:ext cx="7663472" cy="3767979"/>
+      <p:sp>
+        <p:nvSpPr>
+          <p:cNvPr id="147" name="Google Shape;147;g39a2a7d93f5_0_6"/>
+          <p:cNvSpPr txBox="1"/>
+          <p:nvPr>
+            <p:ph idx="1" type="body"/>
+          </p:nvPr>
+        </p:nvSpPr>
+        <p:spPr>
+          <a:xfrm>
+            <a:off x="311700" y="1152475"/>
+            <a:ext cx="8520600" cy="3416400"/>
           </a:xfrm>
           <a:prstGeom prst="rect">
             <a:avLst/>
@@ -12273,10 +12768,209 @@
             <a:noFill/>
           </a:ln>
         </p:spPr>
-      </p:pic>
+        <p:txBody>
+          <a:bodyPr anchorCtr="0" anchor="t" bIns="91425" lIns="91425" spcFirstLastPara="1" rIns="91425" wrap="square" tIns="91425">
+            <a:normAutofit/>
+          </a:bodyPr>
+          <a:lstStyle/>
+          <a:p>
+            <a:pPr indent="-342900" lvl="0" marL="457200" rtl="0" algn="l">
+              <a:lnSpc>
+                <a:spcPct val="115000"/>
+              </a:lnSpc>
+              <a:spcBef>
+                <a:spcPts val="0"/>
+              </a:spcBef>
+              <a:spcAft>
+                <a:spcPts val="0"/>
+              </a:spcAft>
+              <a:buSzPts val="1800"/>
+              <a:buChar char="●"/>
+            </a:pPr>
+            <a:r>
+              <a:rPr lang="vi-VN"/>
+              <a:t>Là một file chứa một chuỗi các cặp </a:t>
+            </a:r>
+            <a:r>
+              <a:rPr b="1" lang="vi-VN"/>
+              <a:t>key-value</a:t>
+            </a:r>
+            <a:r>
+              <a:rPr lang="vi-VN"/>
+              <a:t> được sắp xếp theo </a:t>
+            </a:r>
+            <a:r>
+              <a:rPr b="1" lang="vi-VN"/>
+              <a:t>key</a:t>
+            </a:r>
+            <a:r>
+              <a:rPr lang="vi-VN"/>
+              <a:t> </a:t>
+            </a:r>
+            <a:r>
+              <a:rPr lang="vi-VN"/>
+              <a:t>trong mỗi </a:t>
+            </a:r>
+            <a:r>
+              <a:rPr b="1" lang="vi-VN"/>
+              <a:t>phân đoạn (segment) </a:t>
+            </a:r>
+            <a:r>
+              <a:rPr lang="vi-VN"/>
+              <a:t>được c</a:t>
+            </a:r>
+            <a:r>
+              <a:rPr lang="vi-VN"/>
+              <a:t>ải tiến từ log-structured storage.</a:t>
+            </a:r>
+            <a:endParaRPr/>
+          </a:p>
+          <a:p>
+            <a:pPr indent="-228600" lvl="0" marL="457200" rtl="0" algn="l">
+              <a:lnSpc>
+                <a:spcPct val="115000"/>
+              </a:lnSpc>
+              <a:spcBef>
+                <a:spcPts val="0"/>
+              </a:spcBef>
+              <a:spcAft>
+                <a:spcPts val="0"/>
+              </a:spcAft>
+              <a:buSzPts val="1800"/>
+              <a:buNone/>
+            </a:pPr>
+            <a:r>
+              <a:t/>
+            </a:r>
+            <a:endParaRPr/>
+          </a:p>
+          <a:p>
+            <a:pPr indent="-342900" lvl="0" marL="457200" rtl="0" algn="l">
+              <a:lnSpc>
+                <a:spcPct val="115000"/>
+              </a:lnSpc>
+              <a:spcBef>
+                <a:spcPts val="0"/>
+              </a:spcBef>
+              <a:spcAft>
+                <a:spcPts val="0"/>
+              </a:spcAft>
+              <a:buSzPts val="1800"/>
+              <a:buChar char="●"/>
+            </a:pPr>
+            <a:r>
+              <a:rPr lang="vi-VN"/>
+              <a:t>Việc sắp xếp cho phép sử dụng </a:t>
+            </a:r>
+            <a:r>
+              <a:rPr b="1" lang="vi-VN"/>
+              <a:t>chỉ mục thưa (sparse index) </a:t>
+            </a:r>
+            <a:r>
+              <a:rPr lang="vi-VN"/>
+              <a:t>trong bộ nhớ, giúp tiết kiệm bộ nhớ và </a:t>
+            </a:r>
+            <a:r>
+              <a:rPr b="1" lang="vi-VN"/>
+              <a:t>hỗ trợ nén (compression) </a:t>
+            </a:r>
+            <a:r>
+              <a:rPr lang="vi-VN"/>
+              <a:t>các khối dữ liệu.</a:t>
+            </a:r>
+            <a:endParaRPr/>
+          </a:p>
+          <a:p>
+            <a:pPr indent="-228600" lvl="0" marL="457200" rtl="0" algn="l">
+              <a:lnSpc>
+                <a:spcPct val="115000"/>
+              </a:lnSpc>
+              <a:spcBef>
+                <a:spcPts val="0"/>
+              </a:spcBef>
+              <a:spcAft>
+                <a:spcPts val="0"/>
+              </a:spcAft>
+              <a:buSzPts val="1800"/>
+              <a:buNone/>
+            </a:pPr>
+            <a:r>
+              <a:t/>
+            </a:r>
+            <a:endParaRPr/>
+          </a:p>
+          <a:p>
+            <a:pPr indent="-342900" lvl="0" marL="457200" rtl="0" algn="l">
+              <a:lnSpc>
+                <a:spcPct val="115000"/>
+              </a:lnSpc>
+              <a:spcBef>
+                <a:spcPts val="0"/>
+              </a:spcBef>
+              <a:spcAft>
+                <a:spcPts val="0"/>
+              </a:spcAft>
+              <a:buSzPts val="1800"/>
+              <a:buChar char="●"/>
+            </a:pPr>
+            <a:r>
+              <a:rPr b="1" lang="vi-VN"/>
+              <a:t>LSM-Trees</a:t>
+            </a:r>
+            <a:r>
+              <a:rPr lang="vi-VN"/>
+              <a:t> được xây dựng trên nguyên tắc </a:t>
+            </a:r>
+            <a:r>
+              <a:rPr b="1" lang="vi-VN"/>
+              <a:t>hợp nhất (merging) </a:t>
+            </a:r>
+            <a:r>
+              <a:rPr lang="vi-VN"/>
+              <a:t>và </a:t>
+            </a:r>
+            <a:r>
+              <a:rPr b="1" lang="vi-VN"/>
+              <a:t>nén (compacting) </a:t>
+            </a:r>
+            <a:r>
+              <a:rPr lang="vi-VN"/>
+              <a:t>các tệp </a:t>
+            </a:r>
+            <a:r>
+              <a:rPr b="1" lang="vi-VN"/>
+              <a:t>SSTable đã sắp xếp</a:t>
+            </a:r>
+            <a:r>
+              <a:rPr lang="vi-VN"/>
+              <a:t>.</a:t>
+            </a:r>
+            <a:endParaRPr/>
+          </a:p>
+          <a:p>
+            <a:pPr indent="0" lvl="0" marL="114300" rtl="0" algn="l">
+              <a:lnSpc>
+                <a:spcPct val="115000"/>
+              </a:lnSpc>
+              <a:spcBef>
+                <a:spcPts val="0"/>
+              </a:spcBef>
+              <a:spcAft>
+                <a:spcPts val="0"/>
+              </a:spcAft>
+              <a:buSzPts val="1800"/>
+              <a:buNone/>
+            </a:pPr>
+            <a:r>
+              <a:t/>
+            </a:r>
+            <a:endParaRPr/>
+          </a:p>
+        </p:txBody>
+      </p:sp>
       <p:sp>
         <p:nvSpPr>
-          <p:cNvPr id="148" name="Google Shape;148;p12"/>
+          <p:cNvPr id="148" name="Google Shape;148;g39a2a7d93f5_0_6"/>
           <p:cNvSpPr txBox="1"/>
           <p:nvPr>
             <p:ph idx="12" type="sldNum"/>
@@ -12346,7 +13040,7 @@
       </p:grpSpPr>
       <p:sp>
         <p:nvSpPr>
-          <p:cNvPr id="153" name="Google Shape;153;g3a916ba9e5e_2_18"/>
+          <p:cNvPr id="153" name="Google Shape;153;g3a916ba9e5e_2_6"/>
           <p:cNvSpPr txBox="1"/>
           <p:nvPr>
             <p:ph type="title"/>
@@ -12394,7 +13088,7 @@
       </p:sp>
       <p:pic>
         <p:nvPicPr>
-          <p:cNvPr id="154" name="Google Shape;154;g3a916ba9e5e_2_18"/>
+          <p:cNvPr id="154" name="Google Shape;154;g3a916ba9e5e_2_6"/>
           <p:cNvPicPr preferRelativeResize="0"/>
           <p:nvPr/>
         </p:nvPicPr>
@@ -12408,8 +13102,8 @@
         </p:blipFill>
         <p:spPr>
           <a:xfrm>
-            <a:off x="764675" y="1159250"/>
-            <a:ext cx="7614656" cy="3820974"/>
+            <a:off x="1383850" y="906900"/>
+            <a:ext cx="6376294" cy="4236600"/>
           </a:xfrm>
           <a:prstGeom prst="rect">
             <a:avLst/>
@@ -12422,7 +13116,7 @@
       </p:pic>
       <p:sp>
         <p:nvSpPr>
-          <p:cNvPr id="155" name="Google Shape;155;g3a916ba9e5e_2_18"/>
+          <p:cNvPr id="155" name="Google Shape;155;g3a916ba9e5e_2_6"/>
           <p:cNvSpPr txBox="1"/>
           <p:nvPr>
             <p:ph idx="12" type="sldNum"/>
@@ -12492,7 +13186,7 @@
       </p:grpSpPr>
       <p:sp>
         <p:nvSpPr>
-          <p:cNvPr id="160" name="Google Shape;160;g3a916ba9e5e_2_6"/>
+          <p:cNvPr id="160" name="Google Shape;160;p12"/>
           <p:cNvSpPr txBox="1"/>
           <p:nvPr>
             <p:ph type="title"/>
@@ -12538,9 +13232,54 @@
           </a:p>
         </p:txBody>
       </p:sp>
+      <p:sp>
+        <p:nvSpPr>
+          <p:cNvPr id="161" name="Google Shape;161;p12"/>
+          <p:cNvSpPr txBox="1"/>
+          <p:nvPr>
+            <p:ph idx="12" type="sldNum"/>
+          </p:nvPr>
+        </p:nvSpPr>
+        <p:spPr>
+          <a:xfrm>
+            <a:off x="8472458" y="4663217"/>
+            <a:ext cx="548700" cy="393600"/>
+          </a:xfrm>
+          <a:prstGeom prst="rect">
+            <a:avLst/>
+          </a:prstGeom>
+        </p:spPr>
+        <p:txBody>
+          <a:bodyPr anchorCtr="0" anchor="ctr" bIns="91425" lIns="91425" spcFirstLastPara="1" rIns="91425" wrap="square" tIns="91425">
+            <a:normAutofit/>
+          </a:bodyPr>
+          <a:lstStyle/>
+          <a:p>
+            <a:pPr indent="0" lvl="0" marL="0" rtl="0" algn="r">
+              <a:spcBef>
+                <a:spcPts val="0"/>
+              </a:spcBef>
+              <a:spcAft>
+                <a:spcPts val="0"/>
+              </a:spcAft>
+              <a:buClr>
+                <a:srgbClr val="000000"/>
+              </a:buClr>
+              <a:buSzPts val="1000"/>
+              <a:buFont typeface="Arial"/>
+              <a:buNone/>
+            </a:pPr>
+            <a:fld id="{00000000-1234-1234-1234-123412341234}" type="slidenum">
+              <a:rPr lang="vi-VN"/>
+              <a:t>‹#›</a:t>
+            </a:fld>
+            <a:endParaRPr/>
+          </a:p>
+        </p:txBody>
+      </p:sp>
       <p:pic>
         <p:nvPicPr>
-          <p:cNvPr id="161" name="Google Shape;161;g3a916ba9e5e_2_6"/>
+          <p:cNvPr id="162" name="Google Shape;162;p12"/>
           <p:cNvPicPr preferRelativeResize="0"/>
           <p:nvPr/>
         </p:nvPicPr>
@@ -12554,8 +13293,8 @@
         </p:blipFill>
         <p:spPr>
           <a:xfrm>
-            <a:off x="1383850" y="906900"/>
-            <a:ext cx="6376294" cy="4236600"/>
+            <a:off x="698063" y="1159250"/>
+            <a:ext cx="7747878" cy="3820975"/>
           </a:xfrm>
           <a:prstGeom prst="rect">
             <a:avLst/>
@@ -12566,51 +13305,6 @@
           </a:ln>
         </p:spPr>
       </p:pic>
-      <p:sp>
-        <p:nvSpPr>
-          <p:cNvPr id="162" name="Google Shape;162;g3a916ba9e5e_2_6"/>
-          <p:cNvSpPr txBox="1"/>
-          <p:nvPr>
-            <p:ph idx="12" type="sldNum"/>
-          </p:nvPr>
-        </p:nvSpPr>
-        <p:spPr>
-          <a:xfrm>
-            <a:off x="8472458" y="4663217"/>
-            <a:ext cx="548700" cy="393600"/>
-          </a:xfrm>
-          <a:prstGeom prst="rect">
-            <a:avLst/>
-          </a:prstGeom>
-        </p:spPr>
-        <p:txBody>
-          <a:bodyPr anchorCtr="0" anchor="ctr" bIns="91425" lIns="91425" spcFirstLastPara="1" rIns="91425" wrap="square" tIns="91425">
-            <a:normAutofit/>
-          </a:bodyPr>
-          <a:lstStyle/>
-          <a:p>
-            <a:pPr indent="0" lvl="0" marL="0" rtl="0" algn="r">
-              <a:spcBef>
-                <a:spcPts val="0"/>
-              </a:spcBef>
-              <a:spcAft>
-                <a:spcPts val="0"/>
-              </a:spcAft>
-              <a:buClr>
-                <a:srgbClr val="000000"/>
-              </a:buClr>
-              <a:buSzPts val="1000"/>
-              <a:buFont typeface="Arial"/>
-              <a:buNone/>
-            </a:pPr>
-            <a:fld id="{00000000-1234-1234-1234-123412341234}" type="slidenum">
-              <a:rPr lang="vi-VN"/>
-              <a:t>‹#›</a:t>
-            </a:fld>
-            <a:endParaRPr/>
-          </a:p>
-        </p:txBody>
-      </p:sp>
     </p:spTree>
   </p:cSld>
   <p:clrMapOvr>
@@ -12638,7 +13332,7 @@
       </p:grpSpPr>
       <p:sp>
         <p:nvSpPr>
-          <p:cNvPr id="167" name="Google Shape;167;p13"/>
+          <p:cNvPr id="167" name="Google Shape;167;g39a2a7d93f5_0_27"/>
           <p:cNvSpPr txBox="1"/>
           <p:nvPr>
             <p:ph type="title"/>
@@ -12678,141 +13372,15 @@
             </a:pPr>
             <a:r>
               <a:rPr lang="vi-VN"/>
-              <a:t>3 – c) B-Trees</a:t>
-            </a:r>
-            <a:br>
-              <a:rPr lang="vi-VN"/>
-            </a:br>
+              <a:t>3 – b) SSTables và LSM-Trees</a:t>
+            </a:r>
             <a:endParaRPr/>
           </a:p>
         </p:txBody>
       </p:sp>
       <p:sp>
         <p:nvSpPr>
-          <p:cNvPr id="168" name="Google Shape;168;p13"/>
-          <p:cNvSpPr txBox="1"/>
-          <p:nvPr>
-            <p:ph idx="1" type="body"/>
-          </p:nvPr>
-        </p:nvSpPr>
-        <p:spPr>
-          <a:xfrm>
-            <a:off x="311700" y="1152475"/>
-            <a:ext cx="8520600" cy="3416400"/>
-          </a:xfrm>
-          <a:prstGeom prst="rect">
-            <a:avLst/>
-          </a:prstGeom>
-          <a:noFill/>
-          <a:ln>
-            <a:noFill/>
-          </a:ln>
-        </p:spPr>
-        <p:txBody>
-          <a:bodyPr anchorCtr="0" anchor="t" bIns="91425" lIns="91425" spcFirstLastPara="1" rIns="91425" wrap="square" tIns="91425">
-            <a:normAutofit/>
-          </a:bodyPr>
-          <a:lstStyle/>
-          <a:p>
-            <a:pPr indent="-342900" lvl="0" marL="457200" rtl="0" algn="l">
-              <a:lnSpc>
-                <a:spcPct val="115000"/>
-              </a:lnSpc>
-              <a:spcBef>
-                <a:spcPts val="0"/>
-              </a:spcBef>
-              <a:spcAft>
-                <a:spcPts val="0"/>
-              </a:spcAft>
-              <a:buSzPts val="1800"/>
-              <a:buChar char="●"/>
-            </a:pPr>
-            <a:r>
-              <a:rPr lang="vi-VN"/>
-              <a:t>B-trees chia cơ sở dữ liệu thành </a:t>
-            </a:r>
-            <a:r>
-              <a:rPr b="1" lang="vi-VN"/>
-              <a:t>các khối (blocks) hoặc trang (pages) </a:t>
-            </a:r>
-            <a:r>
-              <a:rPr lang="vi-VN"/>
-              <a:t>có </a:t>
-            </a:r>
-            <a:r>
-              <a:rPr b="1" lang="vi-VN"/>
-              <a:t>kích thước cố định</a:t>
-            </a:r>
-            <a:r>
-              <a:rPr lang="vi-VN"/>
-              <a:t> (thường là 4KB), và sử dụng các </a:t>
-            </a:r>
-            <a:r>
-              <a:rPr b="1" lang="vi-VN"/>
-              <a:t>tham chiếu trang </a:t>
-            </a:r>
-            <a:r>
-              <a:rPr lang="vi-VN"/>
-              <a:t>để tạo thành một cấu trúc </a:t>
-            </a:r>
-            <a:r>
-              <a:rPr b="1" lang="vi-VN"/>
-              <a:t>cây cân bằng (balanced tree).</a:t>
-            </a:r>
-            <a:endParaRPr b="1"/>
-          </a:p>
-          <a:p>
-            <a:pPr indent="-228600" lvl="0" marL="457200" rtl="0" algn="l">
-              <a:lnSpc>
-                <a:spcPct val="115000"/>
-              </a:lnSpc>
-              <a:spcBef>
-                <a:spcPts val="0"/>
-              </a:spcBef>
-              <a:spcAft>
-                <a:spcPts val="0"/>
-              </a:spcAft>
-              <a:buSzPts val="1800"/>
-              <a:buNone/>
-            </a:pPr>
-            <a:r>
-              <a:t/>
-            </a:r>
-            <a:endParaRPr/>
-          </a:p>
-          <a:p>
-            <a:pPr indent="-342900" lvl="0" marL="457200" rtl="0" algn="l">
-              <a:lnSpc>
-                <a:spcPct val="115000"/>
-              </a:lnSpc>
-              <a:spcBef>
-                <a:spcPts val="0"/>
-              </a:spcBef>
-              <a:spcAft>
-                <a:spcPts val="0"/>
-              </a:spcAft>
-              <a:buSzPts val="1800"/>
-              <a:buChar char="●"/>
-            </a:pPr>
-            <a:r>
-              <a:rPr lang="vi-VN"/>
-              <a:t>Để duy trì độ tin cậy, B-Trees thường sử dụng </a:t>
-            </a:r>
-            <a:r>
-              <a:rPr b="1" lang="vi-VN"/>
-              <a:t>write-ahead log (WAL) </a:t>
-            </a:r>
-            <a:r>
-              <a:rPr lang="vi-VN"/>
-              <a:t>để phục hồi sau sự cố.</a:t>
-            </a:r>
-            <a:endParaRPr/>
-          </a:p>
-        </p:txBody>
-      </p:sp>
-      <p:sp>
-        <p:nvSpPr>
-          <p:cNvPr id="169" name="Google Shape;169;p13"/>
+          <p:cNvPr id="168" name="Google Shape;168;g39a2a7d93f5_0_27"/>
           <p:cNvSpPr txBox="1"/>
           <p:nvPr>
             <p:ph idx="12" type="sldNum"/>
@@ -12855,6 +13423,34 @@
           </a:p>
         </p:txBody>
       </p:sp>
+      <p:pic>
+        <p:nvPicPr>
+          <p:cNvPr id="169" name="Google Shape;169;g39a2a7d93f5_0_27"/>
+          <p:cNvPicPr preferRelativeResize="0"/>
+          <p:nvPr/>
+        </p:nvPicPr>
+        <p:blipFill>
+          <a:blip r:embed="rId3">
+            <a:alphaModFix/>
+          </a:blip>
+          <a:stretch>
+            <a:fillRect/>
+          </a:stretch>
+        </p:blipFill>
+        <p:spPr>
+          <a:xfrm>
+            <a:off x="1300525" y="1191875"/>
+            <a:ext cx="6542940" cy="3820975"/>
+          </a:xfrm>
+          <a:prstGeom prst="rect">
+            <a:avLst/>
+          </a:prstGeom>
+          <a:noFill/>
+          <a:ln>
+            <a:noFill/>
+          </a:ln>
+        </p:spPr>
+      </p:pic>
     </p:spTree>
   </p:cSld>
   <p:clrMapOvr>
@@ -12882,7 +13478,7 @@
       </p:grpSpPr>
       <p:sp>
         <p:nvSpPr>
-          <p:cNvPr id="174" name="Google Shape;174;p14"/>
+          <p:cNvPr id="174" name="Google Shape;174;g39a2a7d93f5_0_18"/>
           <p:cNvSpPr txBox="1"/>
           <p:nvPr>
             <p:ph type="title"/>
@@ -12922,7 +13518,7 @@
             </a:pPr>
             <a:r>
               <a:rPr lang="vi-VN"/>
-              <a:t>3 – c) B-Trees</a:t>
+              <a:t>3 – b) SSTables và LSM-Trees</a:t>
             </a:r>
             <a:endParaRPr/>
           </a:p>
@@ -12930,7 +13526,7 @@
       </p:sp>
       <p:pic>
         <p:nvPicPr>
-          <p:cNvPr id="175" name="Google Shape;175;p14"/>
+          <p:cNvPr id="175" name="Google Shape;175;g39a2a7d93f5_0_18"/>
           <p:cNvPicPr preferRelativeResize="0"/>
           <p:nvPr/>
         </p:nvPicPr>
@@ -12943,8 +13539,8 @@
         </p:blipFill>
         <p:spPr>
           <a:xfrm>
-            <a:off x="792784" y="1056256"/>
-            <a:ext cx="7558431" cy="3767979"/>
+            <a:off x="740264" y="1056256"/>
+            <a:ext cx="7663471" cy="3767980"/>
           </a:xfrm>
           <a:prstGeom prst="rect">
             <a:avLst/>
@@ -12957,7 +13553,7 @@
       </p:pic>
       <p:sp>
         <p:nvSpPr>
-          <p:cNvPr id="176" name="Google Shape;176;p14"/>
+          <p:cNvPr id="176" name="Google Shape;176;g39a2a7d93f5_0_18"/>
           <p:cNvSpPr txBox="1"/>
           <p:nvPr>
             <p:ph idx="12" type="sldNum"/>
@@ -13027,7 +13623,7 @@
       </p:grpSpPr>
       <p:sp>
         <p:nvSpPr>
-          <p:cNvPr id="181" name="Google Shape;181;g3a916ba9e5e_2_12"/>
+          <p:cNvPr id="181" name="Google Shape;181;g3a916ba9e5e_2_18"/>
           <p:cNvSpPr txBox="1"/>
           <p:nvPr>
             <p:ph type="title"/>
@@ -13067,7 +13663,7 @@
             </a:pPr>
             <a:r>
               <a:rPr lang="vi-VN"/>
-              <a:t>3 – c) B-Trees</a:t>
+              <a:t>3 – b) SSTables và LSM-Trees</a:t>
             </a:r>
             <a:endParaRPr/>
           </a:p>
@@ -13075,7 +13671,7 @@
       </p:sp>
       <p:pic>
         <p:nvPicPr>
-          <p:cNvPr id="182" name="Google Shape;182;g3a916ba9e5e_2_12"/>
+          <p:cNvPr id="182" name="Google Shape;182;g3a916ba9e5e_2_18"/>
           <p:cNvPicPr preferRelativeResize="0"/>
           <p:nvPr/>
         </p:nvPicPr>
@@ -13089,8 +13685,8 @@
         </p:blipFill>
         <p:spPr>
           <a:xfrm>
-            <a:off x="892251" y="1017725"/>
-            <a:ext cx="7359500" cy="4125775"/>
+            <a:off x="764675" y="1159250"/>
+            <a:ext cx="7614656" cy="3820974"/>
           </a:xfrm>
           <a:prstGeom prst="rect">
             <a:avLst/>
@@ -13103,7 +13699,7 @@
       </p:pic>
       <p:sp>
         <p:nvSpPr>
-          <p:cNvPr id="183" name="Google Shape;183;g3a916ba9e5e_2_12"/>
+          <p:cNvPr id="183" name="Google Shape;183;g3a916ba9e5e_2_18"/>
           <p:cNvSpPr txBox="1"/>
           <p:nvPr>
             <p:ph idx="12" type="sldNum"/>
@@ -13173,7 +13769,7 @@
       </p:grpSpPr>
       <p:sp>
         <p:nvSpPr>
-          <p:cNvPr id="188" name="Google Shape;188;g3a916ba9e5e_2_54"/>
+          <p:cNvPr id="188" name="Google Shape;188;p13"/>
           <p:cNvSpPr txBox="1"/>
           <p:nvPr>
             <p:ph type="title"/>
@@ -13215,13 +13811,139 @@
               <a:rPr lang="vi-VN"/>
               <a:t>3 – c) B-Trees</a:t>
             </a:r>
+            <a:br>
+              <a:rPr lang="vi-VN"/>
+            </a:br>
             <a:endParaRPr/>
           </a:p>
         </p:txBody>
       </p:sp>
       <p:sp>
         <p:nvSpPr>
-          <p:cNvPr id="189" name="Google Shape;189;g3a916ba9e5e_2_54"/>
+          <p:cNvPr id="189" name="Google Shape;189;p13"/>
+          <p:cNvSpPr txBox="1"/>
+          <p:nvPr>
+            <p:ph idx="1" type="body"/>
+          </p:nvPr>
+        </p:nvSpPr>
+        <p:spPr>
+          <a:xfrm>
+            <a:off x="311700" y="1152475"/>
+            <a:ext cx="8520600" cy="3416400"/>
+          </a:xfrm>
+          <a:prstGeom prst="rect">
+            <a:avLst/>
+          </a:prstGeom>
+          <a:noFill/>
+          <a:ln>
+            <a:noFill/>
+          </a:ln>
+        </p:spPr>
+        <p:txBody>
+          <a:bodyPr anchorCtr="0" anchor="t" bIns="91425" lIns="91425" spcFirstLastPara="1" rIns="91425" wrap="square" tIns="91425">
+            <a:normAutofit/>
+          </a:bodyPr>
+          <a:lstStyle/>
+          <a:p>
+            <a:pPr indent="-342900" lvl="0" marL="457200" rtl="0" algn="l">
+              <a:lnSpc>
+                <a:spcPct val="115000"/>
+              </a:lnSpc>
+              <a:spcBef>
+                <a:spcPts val="0"/>
+              </a:spcBef>
+              <a:spcAft>
+                <a:spcPts val="0"/>
+              </a:spcAft>
+              <a:buSzPts val="1800"/>
+              <a:buChar char="●"/>
+            </a:pPr>
+            <a:r>
+              <a:rPr lang="vi-VN"/>
+              <a:t>B-trees chia cơ sở dữ liệu thành </a:t>
+            </a:r>
+            <a:r>
+              <a:rPr b="1" lang="vi-VN"/>
+              <a:t>các khối (blocks) hoặc trang (pages) </a:t>
+            </a:r>
+            <a:r>
+              <a:rPr lang="vi-VN"/>
+              <a:t>có </a:t>
+            </a:r>
+            <a:r>
+              <a:rPr b="1" lang="vi-VN"/>
+              <a:t>kích thước cố định</a:t>
+            </a:r>
+            <a:r>
+              <a:rPr lang="vi-VN"/>
+              <a:t> (thường là 4KB), và sử dụng các </a:t>
+            </a:r>
+            <a:r>
+              <a:rPr b="1" lang="vi-VN"/>
+              <a:t>tham chiếu trang </a:t>
+            </a:r>
+            <a:r>
+              <a:rPr lang="vi-VN"/>
+              <a:t>để tạo thành một cấu trúc </a:t>
+            </a:r>
+            <a:r>
+              <a:rPr b="1" lang="vi-VN"/>
+              <a:t>cây cân bằng (balanced tree).</a:t>
+            </a:r>
+            <a:endParaRPr b="1"/>
+          </a:p>
+          <a:p>
+            <a:pPr indent="-228600" lvl="0" marL="457200" rtl="0" algn="l">
+              <a:lnSpc>
+                <a:spcPct val="115000"/>
+              </a:lnSpc>
+              <a:spcBef>
+                <a:spcPts val="0"/>
+              </a:spcBef>
+              <a:spcAft>
+                <a:spcPts val="0"/>
+              </a:spcAft>
+              <a:buSzPts val="1800"/>
+              <a:buNone/>
+            </a:pPr>
+            <a:r>
+              <a:t/>
+            </a:r>
+            <a:endParaRPr/>
+          </a:p>
+          <a:p>
+            <a:pPr indent="-342900" lvl="0" marL="457200" rtl="0" algn="l">
+              <a:lnSpc>
+                <a:spcPct val="115000"/>
+              </a:lnSpc>
+              <a:spcBef>
+                <a:spcPts val="0"/>
+              </a:spcBef>
+              <a:spcAft>
+                <a:spcPts val="0"/>
+              </a:spcAft>
+              <a:buSzPts val="1800"/>
+              <a:buChar char="●"/>
+            </a:pPr>
+            <a:r>
+              <a:rPr lang="vi-VN"/>
+              <a:t>Để duy trì độ tin cậy, B-Trees thường sử dụng </a:t>
+            </a:r>
+            <a:r>
+              <a:rPr b="1" lang="vi-VN"/>
+              <a:t>write-ahead log (WAL) </a:t>
+            </a:r>
+            <a:r>
+              <a:rPr lang="vi-VN"/>
+              <a:t>để phục hồi sau sự cố.</a:t>
+            </a:r>
+            <a:endParaRPr/>
+          </a:p>
+        </p:txBody>
+      </p:sp>
+      <p:sp>
+        <p:nvSpPr>
+          <p:cNvPr id="190" name="Google Shape;190;p13"/>
           <p:cNvSpPr txBox="1"/>
           <p:nvPr>
             <p:ph idx="12" type="sldNum"/>
@@ -13249,6 +13971,11 @@
               <a:spcAft>
                 <a:spcPts val="0"/>
               </a:spcAft>
+              <a:buClr>
+                <a:srgbClr val="000000"/>
+              </a:buClr>
+              <a:buSzPts val="1000"/>
+              <a:buFont typeface="Arial"/>
               <a:buNone/>
             </a:pPr>
             <a:fld id="{00000000-1234-1234-1234-123412341234}" type="slidenum">
@@ -13259,34 +13986,6 @@
           </a:p>
         </p:txBody>
       </p:sp>
-      <p:pic>
-        <p:nvPicPr>
-          <p:cNvPr id="190" name="Google Shape;190;g3a916ba9e5e_2_54"/>
-          <p:cNvPicPr preferRelativeResize="0"/>
-          <p:nvPr/>
-        </p:nvPicPr>
-        <p:blipFill>
-          <a:blip r:embed="rId3">
-            <a:alphaModFix/>
-          </a:blip>
-          <a:stretch>
-            <a:fillRect/>
-          </a:stretch>
-        </p:blipFill>
-        <p:spPr>
-          <a:xfrm>
-            <a:off x="902838" y="876525"/>
-            <a:ext cx="7338332" cy="4125925"/>
-          </a:xfrm>
-          <a:prstGeom prst="rect">
-            <a:avLst/>
-          </a:prstGeom>
-          <a:noFill/>
-          <a:ln>
-            <a:noFill/>
-          </a:ln>
-        </p:spPr>
-      </p:pic>
     </p:spTree>
   </p:cSld>
   <p:clrMapOvr>
@@ -13314,7 +14013,7 @@
       </p:grpSpPr>
       <p:sp>
         <p:nvSpPr>
-          <p:cNvPr id="195" name="Google Shape;195;p15"/>
+          <p:cNvPr id="195" name="Google Shape;195;p14"/>
           <p:cNvSpPr txBox="1"/>
           <p:nvPr>
             <p:ph type="title"/>
@@ -13354,18 +14053,15 @@
             </a:pPr>
             <a:r>
               <a:rPr lang="vi-VN"/>
-              <a:t>3 – d) So sánh B-Trees và LSM-Trees</a:t>
-            </a:r>
-            <a:br>
-              <a:rPr lang="vi-VN"/>
-            </a:br>
+              <a:t>3 – c) B-Trees</a:t>
+            </a:r>
             <a:endParaRPr/>
           </a:p>
         </p:txBody>
       </p:sp>
       <p:pic>
         <p:nvPicPr>
-          <p:cNvPr id="196" name="Google Shape;196;p15"/>
+          <p:cNvPr id="196" name="Google Shape;196;p14"/>
           <p:cNvPicPr preferRelativeResize="0"/>
           <p:nvPr/>
         </p:nvPicPr>
@@ -13378,8 +14074,8 @@
         </p:blipFill>
         <p:spPr>
           <a:xfrm>
-            <a:off x="1981200" y="1056256"/>
-            <a:ext cx="5181600" cy="3767979"/>
+            <a:off x="792784" y="1056256"/>
+            <a:ext cx="7558431" cy="3767979"/>
           </a:xfrm>
           <a:prstGeom prst="rect">
             <a:avLst/>
@@ -13392,7 +14088,7 @@
       </p:pic>
       <p:sp>
         <p:nvSpPr>
-          <p:cNvPr id="197" name="Google Shape;197;p15"/>
+          <p:cNvPr id="197" name="Google Shape;197;p14"/>
           <p:cNvSpPr txBox="1"/>
           <p:nvPr>
             <p:ph idx="12" type="sldNum"/>
@@ -14739,7 +15435,7 @@
       </p:grpSpPr>
       <p:sp>
         <p:nvSpPr>
-          <p:cNvPr id="202" name="Google Shape;202;p16"/>
+          <p:cNvPr id="202" name="Google Shape;202;g3a916ba9e5e_2_12"/>
           <p:cNvSpPr txBox="1"/>
           <p:nvPr>
             <p:ph type="title"/>
@@ -14779,27 +15475,30 @@
             </a:pPr>
             <a:r>
               <a:rPr lang="vi-VN"/>
-              <a:t>4 – a) Data Warehouse và ETL</a:t>
-            </a:r>
-            <a:br>
-              <a:rPr lang="vi-VN"/>
-            </a:br>
+              <a:t>3 – c) B-Trees</a:t>
+            </a:r>
             <a:endParaRPr/>
           </a:p>
         </p:txBody>
       </p:sp>
-      <p:sp>
-        <p:nvSpPr>
-          <p:cNvPr id="203" name="Google Shape;203;p16"/>
-          <p:cNvSpPr txBox="1"/>
-          <p:nvPr>
-            <p:ph idx="1" type="body"/>
-          </p:nvPr>
-        </p:nvSpPr>
-        <p:spPr>
-          <a:xfrm>
-            <a:off x="311700" y="1152475"/>
-            <a:ext cx="8520600" cy="3416400"/>
+      <p:pic>
+        <p:nvPicPr>
+          <p:cNvPr id="203" name="Google Shape;203;g3a916ba9e5e_2_12"/>
+          <p:cNvPicPr preferRelativeResize="0"/>
+          <p:nvPr/>
+        </p:nvPicPr>
+        <p:blipFill>
+          <a:blip r:embed="rId3">
+            <a:alphaModFix/>
+          </a:blip>
+          <a:stretch>
+            <a:fillRect/>
+          </a:stretch>
+        </p:blipFill>
+        <p:spPr>
+          <a:xfrm>
+            <a:off x="892251" y="1017725"/>
+            <a:ext cx="7359500" cy="4125775"/>
           </a:xfrm>
           <a:prstGeom prst="rect">
             <a:avLst/>
@@ -14809,52 +15508,10 @@
             <a:noFill/>
           </a:ln>
         </p:spPr>
-        <p:txBody>
-          <a:bodyPr anchorCtr="0" anchor="t" bIns="91425" lIns="91425" spcFirstLastPara="1" rIns="91425" wrap="square" tIns="91425">
-            <a:normAutofit/>
-          </a:bodyPr>
-          <a:lstStyle/>
-          <a:p>
-            <a:pPr indent="-342900" lvl="0" marL="457200" rtl="0" algn="l">
-              <a:lnSpc>
-                <a:spcPct val="115000"/>
-              </a:lnSpc>
-              <a:spcBef>
-                <a:spcPts val="0"/>
-              </a:spcBef>
-              <a:spcAft>
-                <a:spcPts val="0"/>
-              </a:spcAft>
-              <a:buSzPts val="1800"/>
-              <a:buChar char="●"/>
-            </a:pPr>
-            <a:r>
-              <a:rPr lang="vi-VN"/>
-              <a:t>Data Warehousing là nơi dữ liệu từ </a:t>
-            </a:r>
-            <a:r>
-              <a:rPr b="1" lang="vi-VN"/>
-              <a:t>các hệ thống OLTP khác nhau </a:t>
-            </a:r>
-            <a:r>
-              <a:rPr lang="vi-VN"/>
-              <a:t>được </a:t>
-            </a:r>
-            <a:r>
-              <a:rPr b="1" lang="vi-VN"/>
-              <a:t>kết hợp</a:t>
-            </a:r>
-            <a:r>
-              <a:rPr lang="vi-VN"/>
-              <a:t> và chuẩn bị cho mục đích phân tích thông qua quy trình Extract-Transform–Load (ETL).</a:t>
-            </a:r>
-            <a:endParaRPr/>
-          </a:p>
-        </p:txBody>
-      </p:sp>
+      </p:pic>
       <p:sp>
         <p:nvSpPr>
-          <p:cNvPr id="204" name="Google Shape;204;p16"/>
+          <p:cNvPr id="204" name="Google Shape;204;g3a916ba9e5e_2_12"/>
           <p:cNvSpPr txBox="1"/>
           <p:nvPr>
             <p:ph idx="12" type="sldNum"/>
@@ -14924,7 +15581,7 @@
       </p:grpSpPr>
       <p:sp>
         <p:nvSpPr>
-          <p:cNvPr id="209" name="Google Shape;209;p17"/>
+          <p:cNvPr id="209" name="Google Shape;209;g3a916ba9e5e_2_54"/>
           <p:cNvSpPr txBox="1"/>
           <p:nvPr>
             <p:ph type="title"/>
@@ -14964,45 +15621,15 @@
             </a:pPr>
             <a:r>
               <a:rPr lang="vi-VN"/>
-              <a:t>4 – a) Data Warehouse và ETL</a:t>
-            </a:r>
-            <a:br>
-              <a:rPr lang="vi-VN"/>
-            </a:br>
+              <a:t>3 – c) B-Trees</a:t>
+            </a:r>
             <a:endParaRPr/>
           </a:p>
         </p:txBody>
       </p:sp>
-      <p:pic>
-        <p:nvPicPr>
-          <p:cNvPr id="210" name="Google Shape;210;p17"/>
-          <p:cNvPicPr preferRelativeResize="0"/>
-          <p:nvPr/>
-        </p:nvPicPr>
-        <p:blipFill rotWithShape="1">
-          <a:blip r:embed="rId3">
-            <a:alphaModFix/>
-          </a:blip>
-          <a:srcRect b="0" l="0" r="0" t="0"/>
-          <a:stretch/>
-        </p:blipFill>
-        <p:spPr>
-          <a:xfrm>
-            <a:off x="945461" y="1056256"/>
-            <a:ext cx="7253076" cy="3767979"/>
-          </a:xfrm>
-          <a:prstGeom prst="rect">
-            <a:avLst/>
-          </a:prstGeom>
-          <a:noFill/>
-          <a:ln>
-            <a:noFill/>
-          </a:ln>
-        </p:spPr>
-      </p:pic>
       <p:sp>
         <p:nvSpPr>
-          <p:cNvPr id="211" name="Google Shape;211;p17"/>
+          <p:cNvPr id="210" name="Google Shape;210;g3a916ba9e5e_2_54"/>
           <p:cNvSpPr txBox="1"/>
           <p:nvPr>
             <p:ph idx="12" type="sldNum"/>
@@ -15030,11 +15657,6 @@
               <a:spcAft>
                 <a:spcPts val="0"/>
               </a:spcAft>
-              <a:buClr>
-                <a:srgbClr val="000000"/>
-              </a:buClr>
-              <a:buSzPts val="1000"/>
-              <a:buFont typeface="Arial"/>
               <a:buNone/>
             </a:pPr>
             <a:fld id="{00000000-1234-1234-1234-123412341234}" type="slidenum">
@@ -15045,6 +15667,34 @@
           </a:p>
         </p:txBody>
       </p:sp>
+      <p:pic>
+        <p:nvPicPr>
+          <p:cNvPr id="211" name="Google Shape;211;g3a916ba9e5e_2_54"/>
+          <p:cNvPicPr preferRelativeResize="0"/>
+          <p:nvPr/>
+        </p:nvPicPr>
+        <p:blipFill>
+          <a:blip r:embed="rId3">
+            <a:alphaModFix/>
+          </a:blip>
+          <a:stretch>
+            <a:fillRect/>
+          </a:stretch>
+        </p:blipFill>
+        <p:spPr>
+          <a:xfrm>
+            <a:off x="902838" y="876525"/>
+            <a:ext cx="7338332" cy="4125925"/>
+          </a:xfrm>
+          <a:prstGeom prst="rect">
+            <a:avLst/>
+          </a:prstGeom>
+          <a:noFill/>
+          <a:ln>
+            <a:noFill/>
+          </a:ln>
+        </p:spPr>
+      </p:pic>
     </p:spTree>
   </p:cSld>
   <p:clrMapOvr>
@@ -15072,7 +15722,7 @@
       </p:grpSpPr>
       <p:sp>
         <p:nvSpPr>
-          <p:cNvPr id="216" name="Google Shape;216;p18"/>
+          <p:cNvPr id="216" name="Google Shape;216;p15"/>
           <p:cNvSpPr txBox="1"/>
           <p:nvPr>
             <p:ph type="title"/>
@@ -15112,7 +15762,7 @@
             </a:pPr>
             <a:r>
               <a:rPr lang="vi-VN"/>
-              <a:t>4 – b) Lược đồ Sao và Bông Tuyết</a:t>
+              <a:t>3 – d) So sánh B-Trees và LSM-Trees</a:t>
             </a:r>
             <a:br>
               <a:rPr lang="vi-VN"/>
@@ -15121,18 +15771,23 @@
           </a:p>
         </p:txBody>
       </p:sp>
-      <p:sp>
-        <p:nvSpPr>
-          <p:cNvPr id="217" name="Google Shape;217;p18"/>
-          <p:cNvSpPr txBox="1"/>
-          <p:nvPr>
-            <p:ph idx="1" type="body"/>
-          </p:nvPr>
-        </p:nvSpPr>
-        <p:spPr>
-          <a:xfrm>
-            <a:off x="311700" y="1152475"/>
-            <a:ext cx="8520600" cy="3416400"/>
+      <p:pic>
+        <p:nvPicPr>
+          <p:cNvPr id="217" name="Google Shape;217;p15"/>
+          <p:cNvPicPr preferRelativeResize="0"/>
+          <p:nvPr/>
+        </p:nvPicPr>
+        <p:blipFill rotWithShape="1">
+          <a:blip r:embed="rId3">
+            <a:alphaModFix/>
+          </a:blip>
+          <a:srcRect b="0" l="0" r="0" t="0"/>
+          <a:stretch/>
+        </p:blipFill>
+        <p:spPr>
+          <a:xfrm>
+            <a:off x="1981200" y="1056256"/>
+            <a:ext cx="5181600" cy="3767979"/>
           </a:xfrm>
           <a:prstGeom prst="rect">
             <a:avLst/>
@@ -15142,60 +15797,10 @@
             <a:noFill/>
           </a:ln>
         </p:spPr>
-        <p:txBody>
-          <a:bodyPr anchorCtr="0" anchor="t" bIns="91425" lIns="91425" spcFirstLastPara="1" rIns="91425" wrap="square" tIns="91425">
-            <a:normAutofit/>
-          </a:bodyPr>
-          <a:lstStyle/>
-          <a:p>
-            <a:pPr indent="-342900" lvl="0" marL="457200" rtl="0" algn="l">
-              <a:lnSpc>
-                <a:spcPct val="115000"/>
-              </a:lnSpc>
-              <a:spcBef>
-                <a:spcPts val="0"/>
-              </a:spcBef>
-              <a:spcAft>
-                <a:spcPts val="0"/>
-              </a:spcAft>
-              <a:buSzPts val="1800"/>
-              <a:buChar char="●"/>
-            </a:pPr>
-            <a:r>
-              <a:rPr lang="vi-VN"/>
-              <a:t>Đây là các mô hình lược đồ phổ biến cho phân tích, với một </a:t>
-            </a:r>
-            <a:r>
-              <a:rPr b="1" lang="vi-VN"/>
-              <a:t>bảng sự kiện (fact table)</a:t>
-            </a:r>
-            <a:r>
-              <a:rPr lang="vi-VN"/>
-              <a:t> lớn ở trung tâm (ví dụ: các giao dịch bán hàng) </a:t>
-            </a:r>
-            <a:r>
-              <a:rPr b="1" lang="vi-VN"/>
-              <a:t>liên kết </a:t>
-            </a:r>
-            <a:r>
-              <a:rPr lang="vi-VN"/>
-              <a:t>đến nhiều </a:t>
-            </a:r>
-            <a:r>
-              <a:rPr b="1" lang="vi-VN"/>
-              <a:t>bảng chiều (dimension tables) </a:t>
-            </a:r>
-            <a:r>
-              <a:rPr lang="vi-VN"/>
-              <a:t>(ví dụ: sản phẩm, ngày, cửa hàng).</a:t>
-            </a:r>
-            <a:endParaRPr/>
-          </a:p>
-        </p:txBody>
-      </p:sp>
+      </p:pic>
       <p:sp>
         <p:nvSpPr>
-          <p:cNvPr id="218" name="Google Shape;218;p18"/>
+          <p:cNvPr id="218" name="Google Shape;218;p15"/>
           <p:cNvSpPr txBox="1"/>
           <p:nvPr>
             <p:ph idx="12" type="sldNum"/>
@@ -15265,7 +15870,7 @@
       </p:grpSpPr>
       <p:sp>
         <p:nvSpPr>
-          <p:cNvPr id="223" name="Google Shape;223;p19"/>
+          <p:cNvPr id="223" name="Google Shape;223;p16"/>
           <p:cNvSpPr txBox="1"/>
           <p:nvPr>
             <p:ph type="title"/>
@@ -15305,7 +15910,7 @@
             </a:pPr>
             <a:r>
               <a:rPr lang="vi-VN"/>
-              <a:t>4 – b) Lược đồ Sao và Bông Tuyết</a:t>
+              <a:t>4 – a) Data Warehouse và ETL</a:t>
             </a:r>
             <a:br>
               <a:rPr lang="vi-VN"/>
@@ -15314,23 +15919,18 @@
           </a:p>
         </p:txBody>
       </p:sp>
-      <p:pic>
-        <p:nvPicPr>
-          <p:cNvPr id="224" name="Google Shape;224;p19"/>
-          <p:cNvPicPr preferRelativeResize="0"/>
-          <p:nvPr/>
-        </p:nvPicPr>
-        <p:blipFill rotWithShape="1">
-          <a:blip r:embed="rId3">
-            <a:alphaModFix/>
-          </a:blip>
-          <a:srcRect b="0" l="0" r="0" t="0"/>
-          <a:stretch/>
-        </p:blipFill>
-        <p:spPr>
-          <a:xfrm>
-            <a:off x="1880585" y="1056256"/>
-            <a:ext cx="5382827" cy="3767979"/>
+      <p:sp>
+        <p:nvSpPr>
+          <p:cNvPr id="224" name="Google Shape;224;p16"/>
+          <p:cNvSpPr txBox="1"/>
+          <p:nvPr>
+            <p:ph idx="1" type="body"/>
+          </p:nvPr>
+        </p:nvSpPr>
+        <p:spPr>
+          <a:xfrm>
+            <a:off x="311700" y="1152475"/>
+            <a:ext cx="8520600" cy="3416400"/>
           </a:xfrm>
           <a:prstGeom prst="rect">
             <a:avLst/>
@@ -15340,10 +15940,52 @@
             <a:noFill/>
           </a:ln>
         </p:spPr>
-      </p:pic>
+        <p:txBody>
+          <a:bodyPr anchorCtr="0" anchor="t" bIns="91425" lIns="91425" spcFirstLastPara="1" rIns="91425" wrap="square" tIns="91425">
+            <a:normAutofit/>
+          </a:bodyPr>
+          <a:lstStyle/>
+          <a:p>
+            <a:pPr indent="-342900" lvl="0" marL="457200" rtl="0" algn="l">
+              <a:lnSpc>
+                <a:spcPct val="115000"/>
+              </a:lnSpc>
+              <a:spcBef>
+                <a:spcPts val="0"/>
+              </a:spcBef>
+              <a:spcAft>
+                <a:spcPts val="0"/>
+              </a:spcAft>
+              <a:buSzPts val="1800"/>
+              <a:buChar char="●"/>
+            </a:pPr>
+            <a:r>
+              <a:rPr lang="vi-VN"/>
+              <a:t>Data Warehousing là nơi dữ liệu từ </a:t>
+            </a:r>
+            <a:r>
+              <a:rPr b="1" lang="vi-VN"/>
+              <a:t>các hệ thống OLTP khác nhau </a:t>
+            </a:r>
+            <a:r>
+              <a:rPr lang="vi-VN"/>
+              <a:t>được </a:t>
+            </a:r>
+            <a:r>
+              <a:rPr b="1" lang="vi-VN"/>
+              <a:t>kết hợp</a:t>
+            </a:r>
+            <a:r>
+              <a:rPr lang="vi-VN"/>
+              <a:t> và chuẩn bị cho mục đích phân tích thông qua quy trình Extract-Transform–Load (ETL).</a:t>
+            </a:r>
+            <a:endParaRPr/>
+          </a:p>
+        </p:txBody>
+      </p:sp>
       <p:sp>
         <p:nvSpPr>
-          <p:cNvPr id="225" name="Google Shape;225;p19"/>
+          <p:cNvPr id="225" name="Google Shape;225;p16"/>
           <p:cNvSpPr txBox="1"/>
           <p:nvPr>
             <p:ph idx="12" type="sldNum"/>
@@ -15413,7 +16055,7 @@
       </p:grpSpPr>
       <p:sp>
         <p:nvSpPr>
-          <p:cNvPr id="230" name="Google Shape;230;g3a916ba9e5e_0_23"/>
+          <p:cNvPr id="230" name="Google Shape;230;p17"/>
           <p:cNvSpPr txBox="1"/>
           <p:nvPr>
             <p:ph type="title"/>
@@ -15453,7 +16095,7 @@
             </a:pPr>
             <a:r>
               <a:rPr lang="vi-VN"/>
-              <a:t>4 – b) Lược đồ Sao và Bông Tuyết</a:t>
+              <a:t>4 – a) Data Warehouse và ETL</a:t>
             </a:r>
             <a:br>
               <a:rPr lang="vi-VN"/>
@@ -15462,69 +16104,23 @@
           </a:p>
         </p:txBody>
       </p:sp>
-      <p:sp>
-        <p:nvSpPr>
-          <p:cNvPr id="231" name="Google Shape;231;g3a916ba9e5e_0_23"/>
-          <p:cNvSpPr txBox="1"/>
-          <p:nvPr>
-            <p:ph idx="12" type="sldNum"/>
-          </p:nvPr>
-        </p:nvSpPr>
-        <p:spPr>
-          <a:xfrm>
-            <a:off x="8472458" y="4663217"/>
-            <a:ext cx="548700" cy="393600"/>
-          </a:xfrm>
-          <a:prstGeom prst="rect">
-            <a:avLst/>
-          </a:prstGeom>
-        </p:spPr>
-        <p:txBody>
-          <a:bodyPr anchorCtr="0" anchor="ctr" bIns="91425" lIns="91425" spcFirstLastPara="1" rIns="91425" wrap="square" tIns="91425">
-            <a:normAutofit/>
-          </a:bodyPr>
-          <a:lstStyle/>
-          <a:p>
-            <a:pPr indent="0" lvl="0" marL="0" rtl="0" algn="r">
-              <a:spcBef>
-                <a:spcPts val="0"/>
-              </a:spcBef>
-              <a:spcAft>
-                <a:spcPts val="0"/>
-              </a:spcAft>
-              <a:buClr>
-                <a:srgbClr val="000000"/>
-              </a:buClr>
-              <a:buSzPts val="1000"/>
-              <a:buFont typeface="Arial"/>
-              <a:buNone/>
-            </a:pPr>
-            <a:fld id="{00000000-1234-1234-1234-123412341234}" type="slidenum">
-              <a:rPr lang="vi-VN"/>
-              <a:t>‹#›</a:t>
-            </a:fld>
-            <a:endParaRPr/>
-          </a:p>
-        </p:txBody>
-      </p:sp>
       <p:pic>
         <p:nvPicPr>
-          <p:cNvPr id="232" name="Google Shape;232;g3a916ba9e5e_0_23"/>
+          <p:cNvPr id="231" name="Google Shape;231;p17"/>
           <p:cNvPicPr preferRelativeResize="0"/>
           <p:nvPr/>
         </p:nvPicPr>
-        <p:blipFill>
+        <p:blipFill rotWithShape="1">
           <a:blip r:embed="rId3">
             <a:alphaModFix/>
           </a:blip>
-          <a:stretch>
-            <a:fillRect/>
-          </a:stretch>
+          <a:srcRect b="0" l="0" r="0" t="0"/>
+          <a:stretch/>
         </p:blipFill>
         <p:spPr>
           <a:xfrm>
-            <a:off x="266000" y="1082388"/>
-            <a:ext cx="3873940" cy="3820976"/>
+            <a:off x="945461" y="1056256"/>
+            <a:ext cx="7253076" cy="3767979"/>
           </a:xfrm>
           <a:prstGeom prst="rect">
             <a:avLst/>
@@ -15535,257 +16131,9 @@
           </a:ln>
         </p:spPr>
       </p:pic>
-      <p:pic>
-        <p:nvPicPr>
-          <p:cNvPr id="233" name="Google Shape;233;g3a916ba9e5e_0_23"/>
-          <p:cNvPicPr preferRelativeResize="0"/>
-          <p:nvPr/>
-        </p:nvPicPr>
-        <p:blipFill>
-          <a:blip r:embed="rId4">
-            <a:alphaModFix/>
-          </a:blip>
-          <a:stretch>
-            <a:fillRect/>
-          </a:stretch>
-        </p:blipFill>
-        <p:spPr>
-          <a:xfrm>
-            <a:off x="4408665" y="1322525"/>
-            <a:ext cx="4151155" cy="3340691"/>
-          </a:xfrm>
-          <a:prstGeom prst="rect">
-            <a:avLst/>
-          </a:prstGeom>
-          <a:noFill/>
-          <a:ln>
-            <a:noFill/>
-          </a:ln>
-        </p:spPr>
-      </p:pic>
-    </p:spTree>
-  </p:cSld>
-  <p:clrMapOvr>
-    <a:masterClrMapping/>
-  </p:clrMapOvr>
-</p:sld>
-</file>
-
-<file path=ppt/slides/slide25.xml><?xml version="1.0" encoding="utf-8"?>
-<p:sld xmlns:a="http://schemas.openxmlformats.org/drawingml/2006/main" xmlns:r="http://schemas.openxmlformats.org/officeDocument/2006/relationships" xmlns:mc="http://schemas.openxmlformats.org/markup-compatibility/2006" xmlns:mv="urn:schemas-microsoft-com:mac:vml" xmlns:p="http://schemas.openxmlformats.org/presentationml/2006/main" xmlns:c="http://schemas.openxmlformats.org/drawingml/2006/chart" xmlns:dgm="http://schemas.openxmlformats.org/drawingml/2006/diagram" xmlns:o="urn:schemas-microsoft-com:office:office" xmlns:v="urn:schemas-microsoft-com:vml" xmlns:pvml="urn:schemas-microsoft-com:office:powerpoint" xmlns:com="http://schemas.openxmlformats.org/drawingml/2006/compatibility" xmlns:p14="http://schemas.microsoft.com/office/powerpoint/2010/main" xmlns:p15="http://schemas.microsoft.com/office/powerpoint/2012/main" xmlns:ahyp="http://schemas.microsoft.com/office/drawing/2018/hyperlinkcolor">
-  <p:cSld>
-    <p:spTree>
-      <p:nvGrpSpPr>
-        <p:cNvPr id="237" name="Shape 237"/>
-        <p:cNvGrpSpPr/>
-        <p:nvPr/>
-      </p:nvGrpSpPr>
-      <p:grpSpPr>
-        <a:xfrm>
-          <a:off x="0" y="0"/>
-          <a:ext cx="0" cy="0"/>
-          <a:chOff x="0" y="0"/>
-          <a:chExt cx="0" cy="0"/>
-        </a:xfrm>
-      </p:grpSpPr>
       <p:sp>
         <p:nvSpPr>
-          <p:cNvPr id="238" name="Google Shape;238;p20"/>
-          <p:cNvSpPr txBox="1"/>
-          <p:nvPr>
-            <p:ph type="title"/>
-          </p:nvPr>
-        </p:nvSpPr>
-        <p:spPr>
-          <a:xfrm>
-            <a:off x="311700" y="445025"/>
-            <a:ext cx="8520600" cy="572700"/>
-          </a:xfrm>
-          <a:prstGeom prst="rect">
-            <a:avLst/>
-          </a:prstGeom>
-          <a:noFill/>
-          <a:ln>
-            <a:noFill/>
-          </a:ln>
-        </p:spPr>
-        <p:txBody>
-          <a:bodyPr anchorCtr="0" anchor="t" bIns="91425" lIns="91425" spcFirstLastPara="1" rIns="91425" wrap="square" tIns="91425">
-            <a:normAutofit fontScale="90000"/>
-          </a:bodyPr>
-          <a:lstStyle/>
-          <a:p>
-            <a:pPr indent="0" lvl="0" marL="0" rtl="0" algn="l">
-              <a:lnSpc>
-                <a:spcPct val="100000"/>
-              </a:lnSpc>
-              <a:spcBef>
-                <a:spcPts val="0"/>
-              </a:spcBef>
-              <a:spcAft>
-                <a:spcPts val="0"/>
-              </a:spcAft>
-              <a:buSzPct val="111111"/>
-              <a:buNone/>
-            </a:pPr>
-            <a:r>
-              <a:rPr lang="vi-VN"/>
-              <a:t>4 – c) Lưu trữ Hướng Cột</a:t>
-            </a:r>
-            <a:br>
-              <a:rPr lang="vi-VN"/>
-            </a:br>
-            <a:endParaRPr/>
-          </a:p>
-        </p:txBody>
-      </p:sp>
-      <p:sp>
-        <p:nvSpPr>
-          <p:cNvPr id="239" name="Google Shape;239;p20"/>
-          <p:cNvSpPr txBox="1"/>
-          <p:nvPr>
-            <p:ph idx="1" type="body"/>
-          </p:nvPr>
-        </p:nvSpPr>
-        <p:spPr>
-          <a:xfrm>
-            <a:off x="311700" y="1152475"/>
-            <a:ext cx="8520600" cy="3416400"/>
-          </a:xfrm>
-          <a:prstGeom prst="rect">
-            <a:avLst/>
-          </a:prstGeom>
-          <a:noFill/>
-          <a:ln>
-            <a:noFill/>
-          </a:ln>
-        </p:spPr>
-        <p:txBody>
-          <a:bodyPr anchorCtr="0" anchor="t" bIns="91425" lIns="91425" spcFirstLastPara="1" rIns="91425" wrap="square" tIns="91425">
-            <a:normAutofit/>
-          </a:bodyPr>
-          <a:lstStyle/>
-          <a:p>
-            <a:pPr indent="-342900" lvl="0" marL="457200" rtl="0" algn="l">
-              <a:lnSpc>
-                <a:spcPct val="115000"/>
-              </a:lnSpc>
-              <a:spcBef>
-                <a:spcPts val="0"/>
-              </a:spcBef>
-              <a:spcAft>
-                <a:spcPts val="0"/>
-              </a:spcAft>
-              <a:buSzPts val="1800"/>
-              <a:buChar char="●"/>
-            </a:pPr>
-            <a:r>
-              <a:rPr lang="vi-VN"/>
-              <a:t>Thay vì lưu trữ tất cả các giá trị của một hàng (row) liền kề nhau (hướng hàng), lưu trữ hướng cột </a:t>
-            </a:r>
-            <a:r>
-              <a:rPr b="1" lang="vi-VN"/>
-              <a:t>lưu trữ tất cả các giá trị </a:t>
-            </a:r>
-            <a:r>
-              <a:rPr lang="vi-VN"/>
-              <a:t>của </a:t>
-            </a:r>
-            <a:r>
-              <a:rPr b="1" lang="vi-VN"/>
-              <a:t>một cột liền kề </a:t>
-            </a:r>
-            <a:r>
-              <a:rPr lang="vi-VN"/>
-              <a:t>nhau.</a:t>
-            </a:r>
-            <a:endParaRPr/>
-          </a:p>
-          <a:p>
-            <a:pPr indent="-342900" lvl="0" marL="457200" rtl="0" algn="l">
-              <a:lnSpc>
-                <a:spcPct val="115000"/>
-              </a:lnSpc>
-              <a:spcBef>
-                <a:spcPts val="0"/>
-              </a:spcBef>
-              <a:spcAft>
-                <a:spcPts val="0"/>
-              </a:spcAft>
-              <a:buSzPts val="1800"/>
-              <a:buChar char="●"/>
-            </a:pPr>
-            <a:r>
-              <a:rPr lang="vi-VN"/>
-              <a:t>Lợi ích chính là </a:t>
-            </a:r>
-            <a:r>
-              <a:rPr b="1" lang="vi-VN"/>
-              <a:t>chỉ cần tải các cột cần thiết cho truy vấn</a:t>
-            </a:r>
-            <a:r>
-              <a:rPr lang="vi-VN"/>
-              <a:t>, giảm đáng kể yêu cầu về </a:t>
-            </a:r>
-            <a:r>
-              <a:rPr b="1" lang="vi-VN"/>
-              <a:t>băng thông đĩa</a:t>
-            </a:r>
-            <a:r>
-              <a:rPr lang="vi-VN"/>
-              <a:t>.</a:t>
-            </a:r>
-            <a:endParaRPr/>
-          </a:p>
-          <a:p>
-            <a:pPr indent="-342900" lvl="0" marL="457200" rtl="0" algn="l">
-              <a:lnSpc>
-                <a:spcPct val="115000"/>
-              </a:lnSpc>
-              <a:spcBef>
-                <a:spcPts val="0"/>
-              </a:spcBef>
-              <a:spcAft>
-                <a:spcPts val="0"/>
-              </a:spcAft>
-              <a:buSzPts val="1800"/>
-              <a:buChar char="●"/>
-            </a:pPr>
-            <a:r>
-              <a:rPr lang="vi-VN"/>
-              <a:t>Cấu trúc này rất phù hợp cho </a:t>
-            </a:r>
-            <a:r>
-              <a:rPr b="1" lang="vi-VN"/>
-              <a:t>Nén cột (Column Compression) </a:t>
-            </a:r>
-            <a:r>
-              <a:rPr lang="vi-VN"/>
-              <a:t>vì các giá trị trong một cột thường </a:t>
-            </a:r>
-            <a:r>
-              <a:rPr b="1" lang="vi-VN"/>
-              <a:t>lặp lại </a:t>
-            </a:r>
-            <a:r>
-              <a:rPr lang="vi-VN"/>
-              <a:t>hoặc có tính </a:t>
-            </a:r>
-            <a:r>
-              <a:rPr b="1" lang="vi-VN"/>
-              <a:t>đồng nhất cao</a:t>
-            </a:r>
-            <a:r>
-              <a:rPr lang="vi-VN"/>
-              <a:t>.</a:t>
-            </a:r>
-            <a:endParaRPr/>
-          </a:p>
-        </p:txBody>
-      </p:sp>
-      <p:sp>
-        <p:nvSpPr>
-          <p:cNvPr id="240" name="Google Shape;240;p20"/>
+          <p:cNvPr id="232" name="Google Shape;232;p17"/>
           <p:cNvSpPr txBox="1"/>
           <p:nvPr>
             <p:ph idx="12" type="sldNum"/>
@@ -15836,12 +16184,12 @@
 </p:sld>
 </file>
 
-<file path=ppt/slides/slide26.xml><?xml version="1.0" encoding="utf-8"?>
+<file path=ppt/slides/slide25.xml><?xml version="1.0" encoding="utf-8"?>
 <p:sld xmlns:a="http://schemas.openxmlformats.org/drawingml/2006/main" xmlns:r="http://schemas.openxmlformats.org/officeDocument/2006/relationships" xmlns:mc="http://schemas.openxmlformats.org/markup-compatibility/2006" xmlns:mv="urn:schemas-microsoft-com:mac:vml" xmlns:p="http://schemas.openxmlformats.org/presentationml/2006/main" xmlns:c="http://schemas.openxmlformats.org/drawingml/2006/chart" xmlns:dgm="http://schemas.openxmlformats.org/drawingml/2006/diagram" xmlns:o="urn:schemas-microsoft-com:office:office" xmlns:v="urn:schemas-microsoft-com:vml" xmlns:pvml="urn:schemas-microsoft-com:office:powerpoint" xmlns:com="http://schemas.openxmlformats.org/drawingml/2006/compatibility" xmlns:p14="http://schemas.microsoft.com/office/powerpoint/2010/main" xmlns:p15="http://schemas.microsoft.com/office/powerpoint/2012/main" xmlns:ahyp="http://schemas.microsoft.com/office/drawing/2018/hyperlinkcolor">
   <p:cSld>
     <p:spTree>
       <p:nvGrpSpPr>
-        <p:cNvPr id="244" name="Shape 244"/>
+        <p:cNvPr id="236" name="Shape 236"/>
         <p:cNvGrpSpPr/>
         <p:nvPr/>
       </p:nvGrpSpPr>
@@ -15855,7 +16203,7 @@
       </p:grpSpPr>
       <p:sp>
         <p:nvSpPr>
-          <p:cNvPr id="245" name="Google Shape;245;p21"/>
+          <p:cNvPr id="237" name="Google Shape;237;g39a2a7d93f5_1_0"/>
           <p:cNvSpPr txBox="1"/>
           <p:nvPr>
             <p:ph type="title"/>
@@ -15895,7 +16243,7 @@
             </a:pPr>
             <a:r>
               <a:rPr lang="vi-VN"/>
-              <a:t>4 – c) Lưu trữ Hướng Cột</a:t>
+              <a:t>4 – a) Data Warehouse và ETL</a:t>
             </a:r>
             <a:br>
               <a:rPr lang="vi-VN"/>
@@ -15904,23 +16252,69 @@
           </a:p>
         </p:txBody>
       </p:sp>
+      <p:sp>
+        <p:nvSpPr>
+          <p:cNvPr id="238" name="Google Shape;238;g39a2a7d93f5_1_0"/>
+          <p:cNvSpPr txBox="1"/>
+          <p:nvPr>
+            <p:ph idx="12" type="sldNum"/>
+          </p:nvPr>
+        </p:nvSpPr>
+        <p:spPr>
+          <a:xfrm>
+            <a:off x="8472458" y="4663217"/>
+            <a:ext cx="548700" cy="393600"/>
+          </a:xfrm>
+          <a:prstGeom prst="rect">
+            <a:avLst/>
+          </a:prstGeom>
+        </p:spPr>
+        <p:txBody>
+          <a:bodyPr anchorCtr="0" anchor="ctr" bIns="91425" lIns="91425" spcFirstLastPara="1" rIns="91425" wrap="square" tIns="91425">
+            <a:normAutofit/>
+          </a:bodyPr>
+          <a:lstStyle/>
+          <a:p>
+            <a:pPr indent="0" lvl="0" marL="0" rtl="0" algn="r">
+              <a:spcBef>
+                <a:spcPts val="0"/>
+              </a:spcBef>
+              <a:spcAft>
+                <a:spcPts val="0"/>
+              </a:spcAft>
+              <a:buClr>
+                <a:srgbClr val="000000"/>
+              </a:buClr>
+              <a:buSzPts val="1000"/>
+              <a:buFont typeface="Arial"/>
+              <a:buNone/>
+            </a:pPr>
+            <a:fld id="{00000000-1234-1234-1234-123412341234}" type="slidenum">
+              <a:rPr lang="vi-VN"/>
+              <a:t>‹#›</a:t>
+            </a:fld>
+            <a:endParaRPr/>
+          </a:p>
+        </p:txBody>
+      </p:sp>
       <p:pic>
         <p:nvPicPr>
-          <p:cNvPr id="246" name="Google Shape;246;p21"/>
+          <p:cNvPr id="239" name="Google Shape;239;g39a2a7d93f5_1_0"/>
           <p:cNvPicPr preferRelativeResize="0"/>
           <p:nvPr/>
         </p:nvPicPr>
-        <p:blipFill rotWithShape="1">
+        <p:blipFill>
           <a:blip r:embed="rId3">
             <a:alphaModFix/>
           </a:blip>
-          <a:srcRect b="0" l="0" r="0" t="0"/>
-          <a:stretch/>
+          <a:stretch>
+            <a:fillRect/>
+          </a:stretch>
         </p:blipFill>
         <p:spPr>
           <a:xfrm>
-            <a:off x="1650254" y="1017725"/>
-            <a:ext cx="6118430" cy="3868570"/>
+            <a:off x="1773900" y="1017725"/>
+            <a:ext cx="5509601" cy="3939800"/>
           </a:xfrm>
           <a:prstGeom prst="rect">
             <a:avLst/>
@@ -15931,9 +16325,157 @@
           </a:ln>
         </p:spPr>
       </p:pic>
+    </p:spTree>
+  </p:cSld>
+  <p:clrMapOvr>
+    <a:masterClrMapping/>
+  </p:clrMapOvr>
+</p:sld>
+</file>
+
+<file path=ppt/slides/slide26.xml><?xml version="1.0" encoding="utf-8"?>
+<p:sld xmlns:a="http://schemas.openxmlformats.org/drawingml/2006/main" xmlns:r="http://schemas.openxmlformats.org/officeDocument/2006/relationships" xmlns:mc="http://schemas.openxmlformats.org/markup-compatibility/2006" xmlns:mv="urn:schemas-microsoft-com:mac:vml" xmlns:p="http://schemas.openxmlformats.org/presentationml/2006/main" xmlns:c="http://schemas.openxmlformats.org/drawingml/2006/chart" xmlns:dgm="http://schemas.openxmlformats.org/drawingml/2006/diagram" xmlns:o="urn:schemas-microsoft-com:office:office" xmlns:v="urn:schemas-microsoft-com:vml" xmlns:pvml="urn:schemas-microsoft-com:office:powerpoint" xmlns:com="http://schemas.openxmlformats.org/drawingml/2006/compatibility" xmlns:p14="http://schemas.microsoft.com/office/powerpoint/2010/main" xmlns:p15="http://schemas.microsoft.com/office/powerpoint/2012/main" xmlns:ahyp="http://schemas.microsoft.com/office/drawing/2018/hyperlinkcolor">
+  <p:cSld>
+    <p:spTree>
+      <p:nvGrpSpPr>
+        <p:cNvPr id="243" name="Shape 243"/>
+        <p:cNvGrpSpPr/>
+        <p:nvPr/>
+      </p:nvGrpSpPr>
+      <p:grpSpPr>
+        <a:xfrm>
+          <a:off x="0" y="0"/>
+          <a:ext cx="0" cy="0"/>
+          <a:chOff x="0" y="0"/>
+          <a:chExt cx="0" cy="0"/>
+        </a:xfrm>
+      </p:grpSpPr>
       <p:sp>
         <p:nvSpPr>
-          <p:cNvPr id="247" name="Google Shape;247;p21"/>
+          <p:cNvPr id="244" name="Google Shape;244;p18"/>
+          <p:cNvSpPr txBox="1"/>
+          <p:nvPr>
+            <p:ph type="title"/>
+          </p:nvPr>
+        </p:nvSpPr>
+        <p:spPr>
+          <a:xfrm>
+            <a:off x="311700" y="445025"/>
+            <a:ext cx="8520600" cy="572700"/>
+          </a:xfrm>
+          <a:prstGeom prst="rect">
+            <a:avLst/>
+          </a:prstGeom>
+          <a:noFill/>
+          <a:ln>
+            <a:noFill/>
+          </a:ln>
+        </p:spPr>
+        <p:txBody>
+          <a:bodyPr anchorCtr="0" anchor="t" bIns="91425" lIns="91425" spcFirstLastPara="1" rIns="91425" wrap="square" tIns="91425">
+            <a:normAutofit fontScale="90000"/>
+          </a:bodyPr>
+          <a:lstStyle/>
+          <a:p>
+            <a:pPr indent="0" lvl="0" marL="0" rtl="0" algn="l">
+              <a:lnSpc>
+                <a:spcPct val="100000"/>
+              </a:lnSpc>
+              <a:spcBef>
+                <a:spcPts val="0"/>
+              </a:spcBef>
+              <a:spcAft>
+                <a:spcPts val="0"/>
+              </a:spcAft>
+              <a:buSzPct val="111111"/>
+              <a:buNone/>
+            </a:pPr>
+            <a:r>
+              <a:rPr lang="vi-VN"/>
+              <a:t>4 – b) Lược đồ Sao và Bông Tuyết</a:t>
+            </a:r>
+            <a:br>
+              <a:rPr lang="vi-VN"/>
+            </a:br>
+            <a:endParaRPr/>
+          </a:p>
+        </p:txBody>
+      </p:sp>
+      <p:sp>
+        <p:nvSpPr>
+          <p:cNvPr id="245" name="Google Shape;245;p18"/>
+          <p:cNvSpPr txBox="1"/>
+          <p:nvPr>
+            <p:ph idx="1" type="body"/>
+          </p:nvPr>
+        </p:nvSpPr>
+        <p:spPr>
+          <a:xfrm>
+            <a:off x="311700" y="1152475"/>
+            <a:ext cx="8520600" cy="3416400"/>
+          </a:xfrm>
+          <a:prstGeom prst="rect">
+            <a:avLst/>
+          </a:prstGeom>
+          <a:noFill/>
+          <a:ln>
+            <a:noFill/>
+          </a:ln>
+        </p:spPr>
+        <p:txBody>
+          <a:bodyPr anchorCtr="0" anchor="t" bIns="91425" lIns="91425" spcFirstLastPara="1" rIns="91425" wrap="square" tIns="91425">
+            <a:normAutofit/>
+          </a:bodyPr>
+          <a:lstStyle/>
+          <a:p>
+            <a:pPr indent="-342900" lvl="0" marL="457200" rtl="0" algn="l">
+              <a:lnSpc>
+                <a:spcPct val="115000"/>
+              </a:lnSpc>
+              <a:spcBef>
+                <a:spcPts val="0"/>
+              </a:spcBef>
+              <a:spcAft>
+                <a:spcPts val="0"/>
+              </a:spcAft>
+              <a:buSzPts val="1800"/>
+              <a:buChar char="●"/>
+            </a:pPr>
+            <a:r>
+              <a:rPr lang="vi-VN"/>
+              <a:t>Đây là các mô hình lược đồ phổ biến cho phân tích, với một </a:t>
+            </a:r>
+            <a:r>
+              <a:rPr b="1" lang="vi-VN"/>
+              <a:t>bảng sự kiện (fact table)</a:t>
+            </a:r>
+            <a:r>
+              <a:rPr lang="vi-VN"/>
+              <a:t> lớn ở trung tâm (ví dụ: các giao dịch bán hàng) </a:t>
+            </a:r>
+            <a:r>
+              <a:rPr b="1" lang="vi-VN"/>
+              <a:t>liên kết </a:t>
+            </a:r>
+            <a:r>
+              <a:rPr lang="vi-VN"/>
+              <a:t>đến nhiều </a:t>
+            </a:r>
+            <a:r>
+              <a:rPr b="1" lang="vi-VN"/>
+              <a:t>bảng chiều (dimension tables) </a:t>
+            </a:r>
+            <a:r>
+              <a:rPr lang="vi-VN"/>
+              <a:t>(ví dụ: sản phẩm, ngày, cửa hàng).</a:t>
+            </a:r>
+            <a:endParaRPr/>
+          </a:p>
+        </p:txBody>
+      </p:sp>
+      <p:sp>
+        <p:nvSpPr>
+          <p:cNvPr id="246" name="Google Shape;246;p18"/>
           <p:cNvSpPr txBox="1"/>
           <p:nvPr>
             <p:ph idx="12" type="sldNum"/>
@@ -15989,7 +16531,7 @@
   <p:cSld>
     <p:spTree>
       <p:nvGrpSpPr>
-        <p:cNvPr id="251" name="Shape 251"/>
+        <p:cNvPr id="250" name="Shape 250"/>
         <p:cNvGrpSpPr/>
         <p:nvPr/>
       </p:nvGrpSpPr>
@@ -16003,7 +16545,7 @@
       </p:grpSpPr>
       <p:sp>
         <p:nvSpPr>
-          <p:cNvPr id="252" name="Google Shape;252;g3a916ba9e5e_0_11"/>
+          <p:cNvPr id="251" name="Google Shape;251;p19"/>
           <p:cNvSpPr txBox="1"/>
           <p:nvPr>
             <p:ph type="title"/>
@@ -16043,7 +16585,7 @@
             </a:pPr>
             <a:r>
               <a:rPr lang="vi-VN"/>
-              <a:t>4 – c) Lưu trữ Hướng Cột</a:t>
+              <a:t>4 – b) Lược đồ Sao và Bông Tuyết</a:t>
             </a:r>
             <a:br>
               <a:rPr lang="vi-VN"/>
@@ -16054,22 +16596,21 @@
       </p:sp>
       <p:pic>
         <p:nvPicPr>
-          <p:cNvPr id="253" name="Google Shape;253;g3a916ba9e5e_0_11"/>
+          <p:cNvPr id="252" name="Google Shape;252;p19"/>
           <p:cNvPicPr preferRelativeResize="0"/>
           <p:nvPr/>
         </p:nvPicPr>
-        <p:blipFill>
+        <p:blipFill rotWithShape="1">
           <a:blip r:embed="rId3">
             <a:alphaModFix/>
           </a:blip>
-          <a:stretch>
-            <a:fillRect/>
-          </a:stretch>
+          <a:srcRect b="0" l="0" r="0" t="0"/>
+          <a:stretch/>
         </p:blipFill>
         <p:spPr>
           <a:xfrm>
-            <a:off x="1655450" y="1017725"/>
-            <a:ext cx="5134748" cy="3820975"/>
+            <a:off x="1880585" y="1056256"/>
+            <a:ext cx="5382827" cy="3767979"/>
           </a:xfrm>
           <a:prstGeom prst="rect">
             <a:avLst/>
@@ -16082,7 +16623,7 @@
       </p:pic>
       <p:sp>
         <p:nvSpPr>
-          <p:cNvPr id="254" name="Google Shape;254;g3a916ba9e5e_0_11"/>
+          <p:cNvPr id="253" name="Google Shape;253;p19"/>
           <p:cNvSpPr txBox="1"/>
           <p:nvPr>
             <p:ph idx="12" type="sldNum"/>
@@ -16138,7 +16679,7 @@
   <p:cSld>
     <p:spTree>
       <p:nvGrpSpPr>
-        <p:cNvPr id="258" name="Shape 258"/>
+        <p:cNvPr id="257" name="Shape 257"/>
         <p:cNvGrpSpPr/>
         <p:nvPr/>
       </p:nvGrpSpPr>
@@ -16152,7 +16693,7 @@
       </p:grpSpPr>
       <p:sp>
         <p:nvSpPr>
-          <p:cNvPr id="259" name="Google Shape;259;g3a916ba9e5e_0_17"/>
+          <p:cNvPr id="258" name="Google Shape;258;g3a916ba9e5e_0_23"/>
           <p:cNvSpPr txBox="1"/>
           <p:nvPr>
             <p:ph type="title"/>
@@ -16192,7 +16733,7 @@
             </a:pPr>
             <a:r>
               <a:rPr lang="vi-VN"/>
-              <a:t>4 – c) Lưu trữ Hướng Cột</a:t>
+              <a:t>4 – b) Lược đồ Sao và Bông Tuyết</a:t>
             </a:r>
             <a:br>
               <a:rPr lang="vi-VN"/>
@@ -16201,9 +16742,54 @@
           </a:p>
         </p:txBody>
       </p:sp>
+      <p:sp>
+        <p:nvSpPr>
+          <p:cNvPr id="259" name="Google Shape;259;g3a916ba9e5e_0_23"/>
+          <p:cNvSpPr txBox="1"/>
+          <p:nvPr>
+            <p:ph idx="12" type="sldNum"/>
+          </p:nvPr>
+        </p:nvSpPr>
+        <p:spPr>
+          <a:xfrm>
+            <a:off x="8472458" y="4663217"/>
+            <a:ext cx="548700" cy="393600"/>
+          </a:xfrm>
+          <a:prstGeom prst="rect">
+            <a:avLst/>
+          </a:prstGeom>
+        </p:spPr>
+        <p:txBody>
+          <a:bodyPr anchorCtr="0" anchor="ctr" bIns="91425" lIns="91425" spcFirstLastPara="1" rIns="91425" wrap="square" tIns="91425">
+            <a:normAutofit/>
+          </a:bodyPr>
+          <a:lstStyle/>
+          <a:p>
+            <a:pPr indent="0" lvl="0" marL="0" rtl="0" algn="r">
+              <a:spcBef>
+                <a:spcPts val="0"/>
+              </a:spcBef>
+              <a:spcAft>
+                <a:spcPts val="0"/>
+              </a:spcAft>
+              <a:buClr>
+                <a:srgbClr val="000000"/>
+              </a:buClr>
+              <a:buSzPts val="1000"/>
+              <a:buFont typeface="Arial"/>
+              <a:buNone/>
+            </a:pPr>
+            <a:fld id="{00000000-1234-1234-1234-123412341234}" type="slidenum">
+              <a:rPr lang="vi-VN"/>
+              <a:t>‹#›</a:t>
+            </a:fld>
+            <a:endParaRPr/>
+          </a:p>
+        </p:txBody>
+      </p:sp>
       <p:pic>
         <p:nvPicPr>
-          <p:cNvPr id="260" name="Google Shape;260;g3a916ba9e5e_0_17"/>
+          <p:cNvPr id="260" name="Google Shape;260;g3a916ba9e5e_0_23"/>
           <p:cNvPicPr preferRelativeResize="0"/>
           <p:nvPr/>
         </p:nvPicPr>
@@ -16217,8 +16803,8 @@
         </p:blipFill>
         <p:spPr>
           <a:xfrm>
-            <a:off x="1804100" y="934175"/>
-            <a:ext cx="5535795" cy="4086976"/>
+            <a:off x="266000" y="1082388"/>
+            <a:ext cx="3873940" cy="3820976"/>
           </a:xfrm>
           <a:prstGeom prst="rect">
             <a:avLst/>
@@ -16229,51 +16815,34 @@
           </a:ln>
         </p:spPr>
       </p:pic>
-      <p:sp>
-        <p:nvSpPr>
-          <p:cNvPr id="261" name="Google Shape;261;g3a916ba9e5e_0_17"/>
-          <p:cNvSpPr txBox="1"/>
-          <p:nvPr>
-            <p:ph idx="12" type="sldNum"/>
-          </p:nvPr>
-        </p:nvSpPr>
-        <p:spPr>
-          <a:xfrm>
-            <a:off x="8472458" y="4663217"/>
-            <a:ext cx="548700" cy="393600"/>
+      <p:pic>
+        <p:nvPicPr>
+          <p:cNvPr id="261" name="Google Shape;261;g3a916ba9e5e_0_23"/>
+          <p:cNvPicPr preferRelativeResize="0"/>
+          <p:nvPr/>
+        </p:nvPicPr>
+        <p:blipFill>
+          <a:blip r:embed="rId4">
+            <a:alphaModFix/>
+          </a:blip>
+          <a:stretch>
+            <a:fillRect/>
+          </a:stretch>
+        </p:blipFill>
+        <p:spPr>
+          <a:xfrm>
+            <a:off x="4408665" y="1322525"/>
+            <a:ext cx="4151155" cy="3340691"/>
           </a:xfrm>
           <a:prstGeom prst="rect">
             <a:avLst/>
           </a:prstGeom>
-        </p:spPr>
-        <p:txBody>
-          <a:bodyPr anchorCtr="0" anchor="ctr" bIns="91425" lIns="91425" spcFirstLastPara="1" rIns="91425" wrap="square" tIns="91425">
-            <a:normAutofit/>
-          </a:bodyPr>
-          <a:lstStyle/>
-          <a:p>
-            <a:pPr indent="0" lvl="0" marL="0" rtl="0" algn="r">
-              <a:spcBef>
-                <a:spcPts val="0"/>
-              </a:spcBef>
-              <a:spcAft>
-                <a:spcPts val="0"/>
-              </a:spcAft>
-              <a:buClr>
-                <a:srgbClr val="000000"/>
-              </a:buClr>
-              <a:buSzPts val="1000"/>
-              <a:buFont typeface="Arial"/>
-              <a:buNone/>
-            </a:pPr>
-            <a:fld id="{00000000-1234-1234-1234-123412341234}" type="slidenum">
-              <a:rPr lang="vi-VN"/>
-              <a:t>‹#›</a:t>
-            </a:fld>
-            <a:endParaRPr/>
-          </a:p>
-        </p:txBody>
-      </p:sp>
+          <a:noFill/>
+          <a:ln>
+            <a:noFill/>
+          </a:ln>
+        </p:spPr>
+      </p:pic>
     </p:spTree>
   </p:cSld>
   <p:clrMapOvr>
@@ -16301,7 +16870,7 @@
       </p:grpSpPr>
       <p:sp>
         <p:nvSpPr>
-          <p:cNvPr id="266" name="Google Shape;266;p22"/>
+          <p:cNvPr id="266" name="Google Shape;266;p20"/>
           <p:cNvSpPr txBox="1"/>
           <p:nvPr>
             <p:ph type="title"/>
@@ -16341,7 +16910,7 @@
             </a:pPr>
             <a:r>
               <a:rPr lang="vi-VN"/>
-              <a:t>4 – d) Khối Dữ liệu và Khung nhìn Vật lý hóa</a:t>
+              <a:t>4 – c) Lưu trữ Hướng Cột</a:t>
             </a:r>
             <a:br>
               <a:rPr lang="vi-VN"/>
@@ -16352,71 +16921,7 @@
       </p:sp>
       <p:sp>
         <p:nvSpPr>
-          <p:cNvPr id="267" name="Google Shape;267;p22"/>
-          <p:cNvSpPr txBox="1"/>
-          <p:nvPr>
-            <p:ph idx="1" type="body"/>
-          </p:nvPr>
-        </p:nvSpPr>
-        <p:spPr>
-          <a:xfrm>
-            <a:off x="311700" y="1152475"/>
-            <a:ext cx="8520600" cy="3416400"/>
-          </a:xfrm>
-          <a:prstGeom prst="rect">
-            <a:avLst/>
-          </a:prstGeom>
-          <a:noFill/>
-          <a:ln>
-            <a:noFill/>
-          </a:ln>
-        </p:spPr>
-        <p:txBody>
-          <a:bodyPr anchorCtr="0" anchor="t" bIns="91425" lIns="91425" spcFirstLastPara="1" rIns="91425" wrap="square" tIns="91425">
-            <a:normAutofit/>
-          </a:bodyPr>
-          <a:lstStyle/>
-          <a:p>
-            <a:pPr indent="-342900" lvl="0" marL="457200" rtl="0" algn="l">
-              <a:lnSpc>
-                <a:spcPct val="115000"/>
-              </a:lnSpc>
-              <a:spcBef>
-                <a:spcPts val="0"/>
-              </a:spcBef>
-              <a:spcAft>
-                <a:spcPts val="0"/>
-              </a:spcAft>
-              <a:buSzPts val="1800"/>
-              <a:buChar char="●"/>
-            </a:pPr>
-            <a:r>
-              <a:rPr lang="vi-VN"/>
-              <a:t>Đây là các kỹ thuật </a:t>
-            </a:r>
-            <a:r>
-              <a:rPr b="1" lang="vi-VN"/>
-              <a:t>tính toán trước (precompute)</a:t>
-            </a:r>
-            <a:r>
-              <a:rPr lang="vi-VN"/>
-              <a:t> các kết quả tổng hợp (ví dụ: tổng doanh số theo ngày và sản phẩm) để </a:t>
-            </a:r>
-            <a:r>
-              <a:rPr b="1" lang="vi-VN"/>
-              <a:t>tăng tốc các truy vấn </a:t>
-            </a:r>
-            <a:r>
-              <a:rPr lang="vi-VN"/>
-              <a:t>phân tích, thay vì tính toán trên dữ liệu thô (raw data) mỗi lần.</a:t>
-            </a:r>
-            <a:endParaRPr/>
-          </a:p>
-        </p:txBody>
-      </p:sp>
-      <p:sp>
-        <p:nvSpPr>
-          <p:cNvPr id="268" name="Google Shape;268;p22"/>
+          <p:cNvPr id="267" name="Google Shape;267;p20"/>
           <p:cNvSpPr txBox="1"/>
           <p:nvPr>
             <p:ph idx="12" type="sldNum"/>
@@ -16459,6 +16964,34 @@
           </a:p>
         </p:txBody>
       </p:sp>
+      <p:pic>
+        <p:nvPicPr>
+          <p:cNvPr id="268" name="Google Shape;268;p20"/>
+          <p:cNvPicPr preferRelativeResize="0"/>
+          <p:nvPr/>
+        </p:nvPicPr>
+        <p:blipFill>
+          <a:blip r:embed="rId3">
+            <a:alphaModFix/>
+          </a:blip>
+          <a:stretch>
+            <a:fillRect/>
+          </a:stretch>
+        </p:blipFill>
+        <p:spPr>
+          <a:xfrm>
+            <a:off x="536250" y="1170125"/>
+            <a:ext cx="8296052" cy="3340692"/>
+          </a:xfrm>
+          <a:prstGeom prst="rect">
+            <a:avLst/>
+          </a:prstGeom>
+          <a:noFill/>
+          <a:ln>
+            <a:noFill/>
+          </a:ln>
+        </p:spPr>
+      </p:pic>
     </p:spTree>
   </p:cSld>
   <p:clrMapOvr>
@@ -16844,7 +17377,7 @@
       </p:grpSpPr>
       <p:sp>
         <p:nvSpPr>
-          <p:cNvPr id="273" name="Google Shape;273;p23"/>
+          <p:cNvPr id="273" name="Google Shape;273;g3abaf853488_0_0"/>
           <p:cNvSpPr txBox="1"/>
           <p:nvPr>
             <p:ph type="title"/>
@@ -16884,7 +17417,7 @@
             </a:pPr>
             <a:r>
               <a:rPr lang="vi-VN"/>
-              <a:t>4 – d) Khối Dữ liệu và Khung nhìn Vật lý hóa</a:t>
+              <a:t>4 – c) Lưu trữ Hướng Cột</a:t>
             </a:r>
             <a:br>
               <a:rPr lang="vi-VN"/>
@@ -16893,23 +17426,18 @@
           </a:p>
         </p:txBody>
       </p:sp>
-      <p:pic>
-        <p:nvPicPr>
-          <p:cNvPr id="274" name="Google Shape;274;p23"/>
-          <p:cNvPicPr preferRelativeResize="0"/>
-          <p:nvPr/>
-        </p:nvPicPr>
-        <p:blipFill rotWithShape="1">
-          <a:blip r:embed="rId3">
-            <a:alphaModFix/>
-          </a:blip>
-          <a:srcRect b="0" l="0" r="0" t="0"/>
-          <a:stretch/>
-        </p:blipFill>
-        <p:spPr>
-          <a:xfrm>
-            <a:off x="1072957" y="1017725"/>
-            <a:ext cx="6998085" cy="3680750"/>
+      <p:sp>
+        <p:nvSpPr>
+          <p:cNvPr id="274" name="Google Shape;274;g3abaf853488_0_0"/>
+          <p:cNvSpPr txBox="1"/>
+          <p:nvPr>
+            <p:ph idx="1" type="body"/>
+          </p:nvPr>
+        </p:nvSpPr>
+        <p:spPr>
+          <a:xfrm>
+            <a:off x="311700" y="1152475"/>
+            <a:ext cx="8520600" cy="3416400"/>
           </a:xfrm>
           <a:prstGeom prst="rect">
             <a:avLst/>
@@ -16919,10 +17447,132 @@
             <a:noFill/>
           </a:ln>
         </p:spPr>
-      </p:pic>
+        <p:txBody>
+          <a:bodyPr anchorCtr="0" anchor="t" bIns="91425" lIns="91425" spcFirstLastPara="1" rIns="91425" wrap="square" tIns="91425">
+            <a:normAutofit/>
+          </a:bodyPr>
+          <a:lstStyle/>
+          <a:p>
+            <a:pPr indent="-342900" lvl="0" marL="457200" rtl="0" algn="l">
+              <a:lnSpc>
+                <a:spcPct val="115000"/>
+              </a:lnSpc>
+              <a:spcBef>
+                <a:spcPts val="0"/>
+              </a:spcBef>
+              <a:spcAft>
+                <a:spcPts val="0"/>
+              </a:spcAft>
+              <a:buSzPts val="1800"/>
+              <a:buChar char="●"/>
+            </a:pPr>
+            <a:r>
+              <a:rPr lang="vi-VN"/>
+              <a:t>Thay vì lưu trữ tất cả các giá trị của một hàng (row) liền kề nhau (hướng hàng), lưu trữ hướng cột </a:t>
+            </a:r>
+            <a:r>
+              <a:rPr b="1" lang="vi-VN"/>
+              <a:t>lưu trữ tất cả các giá trị </a:t>
+            </a:r>
+            <a:r>
+              <a:rPr lang="vi-VN"/>
+              <a:t>của </a:t>
+            </a:r>
+            <a:r>
+              <a:rPr b="1" lang="vi-VN"/>
+              <a:t>một cột liền kề </a:t>
+            </a:r>
+            <a:r>
+              <a:rPr lang="vi-VN"/>
+              <a:t>nhau.</a:t>
+            </a:r>
+            <a:endParaRPr/>
+          </a:p>
+          <a:p>
+            <a:pPr indent="-342900" lvl="0" marL="457200" rtl="0" algn="l">
+              <a:lnSpc>
+                <a:spcPct val="115000"/>
+              </a:lnSpc>
+              <a:spcBef>
+                <a:spcPts val="0"/>
+              </a:spcBef>
+              <a:spcAft>
+                <a:spcPts val="0"/>
+              </a:spcAft>
+              <a:buSzPts val="1800"/>
+              <a:buChar char="●"/>
+            </a:pPr>
+            <a:r>
+              <a:rPr lang="vi-VN"/>
+              <a:t>Lợi ích chính là </a:t>
+            </a:r>
+            <a:r>
+              <a:rPr b="1" lang="vi-VN"/>
+              <a:t>chỉ cần tải các cột cần thiết cho truy vấn</a:t>
+            </a:r>
+            <a:r>
+              <a:rPr lang="vi-VN"/>
+              <a:t>, giảm đáng kể yêu cầu về </a:t>
+            </a:r>
+            <a:r>
+              <a:rPr b="1" lang="vi-VN"/>
+              <a:t>băng thông đĩa</a:t>
+            </a:r>
+            <a:r>
+              <a:rPr lang="vi-VN"/>
+              <a:t>.</a:t>
+            </a:r>
+            <a:endParaRPr/>
+          </a:p>
+          <a:p>
+            <a:pPr indent="-342900" lvl="0" marL="457200" rtl="0" algn="l">
+              <a:lnSpc>
+                <a:spcPct val="115000"/>
+              </a:lnSpc>
+              <a:spcBef>
+                <a:spcPts val="0"/>
+              </a:spcBef>
+              <a:spcAft>
+                <a:spcPts val="0"/>
+              </a:spcAft>
+              <a:buSzPts val="1800"/>
+              <a:buChar char="●"/>
+            </a:pPr>
+            <a:r>
+              <a:rPr lang="vi-VN"/>
+              <a:t>Cấu trúc này rất phù hợp cho </a:t>
+            </a:r>
+            <a:r>
+              <a:rPr b="1" lang="vi-VN"/>
+              <a:t>Nén cột (Column Compression) </a:t>
+            </a:r>
+            <a:r>
+              <a:rPr lang="vi-VN"/>
+              <a:t>vì các giá trị trong một cột thường </a:t>
+            </a:r>
+            <a:r>
+              <a:rPr b="1" lang="vi-VN"/>
+              <a:t>lặp lại </a:t>
+            </a:r>
+            <a:r>
+              <a:rPr lang="vi-VN"/>
+              <a:t>hoặc có tính </a:t>
+            </a:r>
+            <a:r>
+              <a:rPr b="1" lang="vi-VN"/>
+              <a:t>đồng nhất cao</a:t>
+            </a:r>
+            <a:r>
+              <a:rPr lang="vi-VN"/>
+              <a:t>.</a:t>
+            </a:r>
+            <a:endParaRPr/>
+          </a:p>
+        </p:txBody>
+      </p:sp>
       <p:sp>
         <p:nvSpPr>
-          <p:cNvPr id="275" name="Google Shape;275;p23"/>
+          <p:cNvPr id="275" name="Google Shape;275;g3abaf853488_0_0"/>
           <p:cNvSpPr txBox="1"/>
           <p:nvPr>
             <p:ph idx="12" type="sldNum"/>
@@ -16992,7 +17642,7 @@
       </p:grpSpPr>
       <p:sp>
         <p:nvSpPr>
-          <p:cNvPr id="280" name="Google Shape;280;p24"/>
+          <p:cNvPr id="280" name="Google Shape;280;p21"/>
           <p:cNvSpPr txBox="1"/>
           <p:nvPr>
             <p:ph type="title"/>
@@ -17032,24 +17682,32 @@
             </a:pPr>
             <a:r>
               <a:rPr lang="vi-VN"/>
-              <a:t>Tham khảo</a:t>
-            </a:r>
+              <a:t>4 – c) Lưu trữ Hướng Cột</a:t>
+            </a:r>
+            <a:br>
+              <a:rPr lang="vi-VN"/>
+            </a:br>
             <a:endParaRPr/>
           </a:p>
         </p:txBody>
       </p:sp>
-      <p:sp>
-        <p:nvSpPr>
-          <p:cNvPr id="281" name="Google Shape;281;p24"/>
-          <p:cNvSpPr txBox="1"/>
-          <p:nvPr>
-            <p:ph idx="1" type="body"/>
-          </p:nvPr>
-        </p:nvSpPr>
-        <p:spPr>
-          <a:xfrm>
-            <a:off x="311700" y="1152475"/>
-            <a:ext cx="8520600" cy="3416400"/>
+      <p:pic>
+        <p:nvPicPr>
+          <p:cNvPr id="281" name="Google Shape;281;p21"/>
+          <p:cNvPicPr preferRelativeResize="0"/>
+          <p:nvPr/>
+        </p:nvPicPr>
+        <p:blipFill rotWithShape="1">
+          <a:blip r:embed="rId3">
+            <a:alphaModFix/>
+          </a:blip>
+          <a:srcRect b="0" l="0" r="0" t="0"/>
+          <a:stretch/>
+        </p:blipFill>
+        <p:spPr>
+          <a:xfrm>
+            <a:off x="1650254" y="1017725"/>
+            <a:ext cx="6118430" cy="3868570"/>
           </a:xfrm>
           <a:prstGeom prst="rect">
             <a:avLst/>
@@ -17059,6 +17717,447 @@
             <a:noFill/>
           </a:ln>
         </p:spPr>
+      </p:pic>
+      <p:sp>
+        <p:nvSpPr>
+          <p:cNvPr id="282" name="Google Shape;282;p21"/>
+          <p:cNvSpPr txBox="1"/>
+          <p:nvPr>
+            <p:ph idx="12" type="sldNum"/>
+          </p:nvPr>
+        </p:nvSpPr>
+        <p:spPr>
+          <a:xfrm>
+            <a:off x="8472458" y="4663217"/>
+            <a:ext cx="548700" cy="393600"/>
+          </a:xfrm>
+          <a:prstGeom prst="rect">
+            <a:avLst/>
+          </a:prstGeom>
+        </p:spPr>
+        <p:txBody>
+          <a:bodyPr anchorCtr="0" anchor="ctr" bIns="91425" lIns="91425" spcFirstLastPara="1" rIns="91425" wrap="square" tIns="91425">
+            <a:normAutofit/>
+          </a:bodyPr>
+          <a:lstStyle/>
+          <a:p>
+            <a:pPr indent="0" lvl="0" marL="0" rtl="0" algn="r">
+              <a:spcBef>
+                <a:spcPts val="0"/>
+              </a:spcBef>
+              <a:spcAft>
+                <a:spcPts val="0"/>
+              </a:spcAft>
+              <a:buClr>
+                <a:srgbClr val="000000"/>
+              </a:buClr>
+              <a:buSzPts val="1000"/>
+              <a:buFont typeface="Arial"/>
+              <a:buNone/>
+            </a:pPr>
+            <a:fld id="{00000000-1234-1234-1234-123412341234}" type="slidenum">
+              <a:rPr lang="vi-VN"/>
+              <a:t>‹#›</a:t>
+            </a:fld>
+            <a:endParaRPr/>
+          </a:p>
+        </p:txBody>
+      </p:sp>
+    </p:spTree>
+  </p:cSld>
+  <p:clrMapOvr>
+    <a:masterClrMapping/>
+  </p:clrMapOvr>
+</p:sld>
+</file>
+
+<file path=ppt/slides/slide32.xml><?xml version="1.0" encoding="utf-8"?>
+<p:sld xmlns:a="http://schemas.openxmlformats.org/drawingml/2006/main" xmlns:r="http://schemas.openxmlformats.org/officeDocument/2006/relationships" xmlns:mc="http://schemas.openxmlformats.org/markup-compatibility/2006" xmlns:mv="urn:schemas-microsoft-com:mac:vml" xmlns:p="http://schemas.openxmlformats.org/presentationml/2006/main" xmlns:c="http://schemas.openxmlformats.org/drawingml/2006/chart" xmlns:dgm="http://schemas.openxmlformats.org/drawingml/2006/diagram" xmlns:o="urn:schemas-microsoft-com:office:office" xmlns:v="urn:schemas-microsoft-com:vml" xmlns:pvml="urn:schemas-microsoft-com:office:powerpoint" xmlns:com="http://schemas.openxmlformats.org/drawingml/2006/compatibility" xmlns:p14="http://schemas.microsoft.com/office/powerpoint/2010/main" xmlns:p15="http://schemas.microsoft.com/office/powerpoint/2012/main" xmlns:ahyp="http://schemas.microsoft.com/office/drawing/2018/hyperlinkcolor">
+  <p:cSld>
+    <p:spTree>
+      <p:nvGrpSpPr>
+        <p:cNvPr id="286" name="Shape 286"/>
+        <p:cNvGrpSpPr/>
+        <p:nvPr/>
+      </p:nvGrpSpPr>
+      <p:grpSpPr>
+        <a:xfrm>
+          <a:off x="0" y="0"/>
+          <a:ext cx="0" cy="0"/>
+          <a:chOff x="0" y="0"/>
+          <a:chExt cx="0" cy="0"/>
+        </a:xfrm>
+      </p:grpSpPr>
+      <p:sp>
+        <p:nvSpPr>
+          <p:cNvPr id="287" name="Google Shape;287;g3a916ba9e5e_0_11"/>
+          <p:cNvSpPr txBox="1"/>
+          <p:nvPr>
+            <p:ph type="title"/>
+          </p:nvPr>
+        </p:nvSpPr>
+        <p:spPr>
+          <a:xfrm>
+            <a:off x="311700" y="445025"/>
+            <a:ext cx="8520600" cy="572700"/>
+          </a:xfrm>
+          <a:prstGeom prst="rect">
+            <a:avLst/>
+          </a:prstGeom>
+          <a:noFill/>
+          <a:ln>
+            <a:noFill/>
+          </a:ln>
+        </p:spPr>
+        <p:txBody>
+          <a:bodyPr anchorCtr="0" anchor="t" bIns="91425" lIns="91425" spcFirstLastPara="1" rIns="91425" wrap="square" tIns="91425">
+            <a:normAutofit fontScale="90000"/>
+          </a:bodyPr>
+          <a:lstStyle/>
+          <a:p>
+            <a:pPr indent="0" lvl="0" marL="0" rtl="0" algn="l">
+              <a:lnSpc>
+                <a:spcPct val="100000"/>
+              </a:lnSpc>
+              <a:spcBef>
+                <a:spcPts val="0"/>
+              </a:spcBef>
+              <a:spcAft>
+                <a:spcPts val="0"/>
+              </a:spcAft>
+              <a:buSzPct val="111111"/>
+              <a:buNone/>
+            </a:pPr>
+            <a:r>
+              <a:rPr lang="vi-VN"/>
+              <a:t>4 – c) Lưu trữ Hướng Cột</a:t>
+            </a:r>
+            <a:br>
+              <a:rPr lang="vi-VN"/>
+            </a:br>
+            <a:endParaRPr/>
+          </a:p>
+        </p:txBody>
+      </p:sp>
+      <p:pic>
+        <p:nvPicPr>
+          <p:cNvPr id="288" name="Google Shape;288;g3a916ba9e5e_0_11"/>
+          <p:cNvPicPr preferRelativeResize="0"/>
+          <p:nvPr/>
+        </p:nvPicPr>
+        <p:blipFill>
+          <a:blip r:embed="rId3">
+            <a:alphaModFix/>
+          </a:blip>
+          <a:stretch>
+            <a:fillRect/>
+          </a:stretch>
+        </p:blipFill>
+        <p:spPr>
+          <a:xfrm>
+            <a:off x="1655450" y="1017725"/>
+            <a:ext cx="5134748" cy="3820975"/>
+          </a:xfrm>
+          <a:prstGeom prst="rect">
+            <a:avLst/>
+          </a:prstGeom>
+          <a:noFill/>
+          <a:ln>
+            <a:noFill/>
+          </a:ln>
+        </p:spPr>
+      </p:pic>
+      <p:sp>
+        <p:nvSpPr>
+          <p:cNvPr id="289" name="Google Shape;289;g3a916ba9e5e_0_11"/>
+          <p:cNvSpPr txBox="1"/>
+          <p:nvPr>
+            <p:ph idx="12" type="sldNum"/>
+          </p:nvPr>
+        </p:nvSpPr>
+        <p:spPr>
+          <a:xfrm>
+            <a:off x="8472458" y="4663217"/>
+            <a:ext cx="548700" cy="393600"/>
+          </a:xfrm>
+          <a:prstGeom prst="rect">
+            <a:avLst/>
+          </a:prstGeom>
+        </p:spPr>
+        <p:txBody>
+          <a:bodyPr anchorCtr="0" anchor="ctr" bIns="91425" lIns="91425" spcFirstLastPara="1" rIns="91425" wrap="square" tIns="91425">
+            <a:normAutofit/>
+          </a:bodyPr>
+          <a:lstStyle/>
+          <a:p>
+            <a:pPr indent="0" lvl="0" marL="0" rtl="0" algn="r">
+              <a:spcBef>
+                <a:spcPts val="0"/>
+              </a:spcBef>
+              <a:spcAft>
+                <a:spcPts val="0"/>
+              </a:spcAft>
+              <a:buClr>
+                <a:srgbClr val="000000"/>
+              </a:buClr>
+              <a:buSzPts val="1000"/>
+              <a:buFont typeface="Arial"/>
+              <a:buNone/>
+            </a:pPr>
+            <a:fld id="{00000000-1234-1234-1234-123412341234}" type="slidenum">
+              <a:rPr lang="vi-VN"/>
+              <a:t>‹#›</a:t>
+            </a:fld>
+            <a:endParaRPr/>
+          </a:p>
+        </p:txBody>
+      </p:sp>
+    </p:spTree>
+  </p:cSld>
+  <p:clrMapOvr>
+    <a:masterClrMapping/>
+  </p:clrMapOvr>
+</p:sld>
+</file>
+
+<file path=ppt/slides/slide33.xml><?xml version="1.0" encoding="utf-8"?>
+<p:sld xmlns:a="http://schemas.openxmlformats.org/drawingml/2006/main" xmlns:r="http://schemas.openxmlformats.org/officeDocument/2006/relationships" xmlns:mc="http://schemas.openxmlformats.org/markup-compatibility/2006" xmlns:mv="urn:schemas-microsoft-com:mac:vml" xmlns:p="http://schemas.openxmlformats.org/presentationml/2006/main" xmlns:c="http://schemas.openxmlformats.org/drawingml/2006/chart" xmlns:dgm="http://schemas.openxmlformats.org/drawingml/2006/diagram" xmlns:o="urn:schemas-microsoft-com:office:office" xmlns:v="urn:schemas-microsoft-com:vml" xmlns:pvml="urn:schemas-microsoft-com:office:powerpoint" xmlns:com="http://schemas.openxmlformats.org/drawingml/2006/compatibility" xmlns:p14="http://schemas.microsoft.com/office/powerpoint/2010/main" xmlns:p15="http://schemas.microsoft.com/office/powerpoint/2012/main" xmlns:ahyp="http://schemas.microsoft.com/office/drawing/2018/hyperlinkcolor">
+  <p:cSld>
+    <p:spTree>
+      <p:nvGrpSpPr>
+        <p:cNvPr id="293" name="Shape 293"/>
+        <p:cNvGrpSpPr/>
+        <p:nvPr/>
+      </p:nvGrpSpPr>
+      <p:grpSpPr>
+        <a:xfrm>
+          <a:off x="0" y="0"/>
+          <a:ext cx="0" cy="0"/>
+          <a:chOff x="0" y="0"/>
+          <a:chExt cx="0" cy="0"/>
+        </a:xfrm>
+      </p:grpSpPr>
+      <p:sp>
+        <p:nvSpPr>
+          <p:cNvPr id="294" name="Google Shape;294;g3a916ba9e5e_0_17"/>
+          <p:cNvSpPr txBox="1"/>
+          <p:nvPr>
+            <p:ph type="title"/>
+          </p:nvPr>
+        </p:nvSpPr>
+        <p:spPr>
+          <a:xfrm>
+            <a:off x="311700" y="445025"/>
+            <a:ext cx="8520600" cy="572700"/>
+          </a:xfrm>
+          <a:prstGeom prst="rect">
+            <a:avLst/>
+          </a:prstGeom>
+          <a:noFill/>
+          <a:ln>
+            <a:noFill/>
+          </a:ln>
+        </p:spPr>
+        <p:txBody>
+          <a:bodyPr anchorCtr="0" anchor="t" bIns="91425" lIns="91425" spcFirstLastPara="1" rIns="91425" wrap="square" tIns="91425">
+            <a:normAutofit fontScale="90000"/>
+          </a:bodyPr>
+          <a:lstStyle/>
+          <a:p>
+            <a:pPr indent="0" lvl="0" marL="0" rtl="0" algn="l">
+              <a:lnSpc>
+                <a:spcPct val="100000"/>
+              </a:lnSpc>
+              <a:spcBef>
+                <a:spcPts val="0"/>
+              </a:spcBef>
+              <a:spcAft>
+                <a:spcPts val="0"/>
+              </a:spcAft>
+              <a:buSzPct val="111111"/>
+              <a:buNone/>
+            </a:pPr>
+            <a:r>
+              <a:rPr lang="vi-VN"/>
+              <a:t>4 – c) Lưu trữ Hướng Cột</a:t>
+            </a:r>
+            <a:br>
+              <a:rPr lang="vi-VN"/>
+            </a:br>
+            <a:endParaRPr/>
+          </a:p>
+        </p:txBody>
+      </p:sp>
+      <p:pic>
+        <p:nvPicPr>
+          <p:cNvPr id="295" name="Google Shape;295;g3a916ba9e5e_0_17"/>
+          <p:cNvPicPr preferRelativeResize="0"/>
+          <p:nvPr/>
+        </p:nvPicPr>
+        <p:blipFill>
+          <a:blip r:embed="rId3">
+            <a:alphaModFix/>
+          </a:blip>
+          <a:stretch>
+            <a:fillRect/>
+          </a:stretch>
+        </p:blipFill>
+        <p:spPr>
+          <a:xfrm>
+            <a:off x="1804100" y="934175"/>
+            <a:ext cx="5535795" cy="4086976"/>
+          </a:xfrm>
+          <a:prstGeom prst="rect">
+            <a:avLst/>
+          </a:prstGeom>
+          <a:noFill/>
+          <a:ln>
+            <a:noFill/>
+          </a:ln>
+        </p:spPr>
+      </p:pic>
+      <p:sp>
+        <p:nvSpPr>
+          <p:cNvPr id="296" name="Google Shape;296;g3a916ba9e5e_0_17"/>
+          <p:cNvSpPr txBox="1"/>
+          <p:nvPr>
+            <p:ph idx="12" type="sldNum"/>
+          </p:nvPr>
+        </p:nvSpPr>
+        <p:spPr>
+          <a:xfrm>
+            <a:off x="8472458" y="4663217"/>
+            <a:ext cx="548700" cy="393600"/>
+          </a:xfrm>
+          <a:prstGeom prst="rect">
+            <a:avLst/>
+          </a:prstGeom>
+        </p:spPr>
+        <p:txBody>
+          <a:bodyPr anchorCtr="0" anchor="ctr" bIns="91425" lIns="91425" spcFirstLastPara="1" rIns="91425" wrap="square" tIns="91425">
+            <a:normAutofit/>
+          </a:bodyPr>
+          <a:lstStyle/>
+          <a:p>
+            <a:pPr indent="0" lvl="0" marL="0" rtl="0" algn="r">
+              <a:spcBef>
+                <a:spcPts val="0"/>
+              </a:spcBef>
+              <a:spcAft>
+                <a:spcPts val="0"/>
+              </a:spcAft>
+              <a:buClr>
+                <a:srgbClr val="000000"/>
+              </a:buClr>
+              <a:buSzPts val="1000"/>
+              <a:buFont typeface="Arial"/>
+              <a:buNone/>
+            </a:pPr>
+            <a:fld id="{00000000-1234-1234-1234-123412341234}" type="slidenum">
+              <a:rPr lang="vi-VN"/>
+              <a:t>‹#›</a:t>
+            </a:fld>
+            <a:endParaRPr/>
+          </a:p>
+        </p:txBody>
+      </p:sp>
+    </p:spTree>
+  </p:cSld>
+  <p:clrMapOvr>
+    <a:masterClrMapping/>
+  </p:clrMapOvr>
+</p:sld>
+</file>
+
+<file path=ppt/slides/slide34.xml><?xml version="1.0" encoding="utf-8"?>
+<p:sld xmlns:a="http://schemas.openxmlformats.org/drawingml/2006/main" xmlns:r="http://schemas.openxmlformats.org/officeDocument/2006/relationships" xmlns:mc="http://schemas.openxmlformats.org/markup-compatibility/2006" xmlns:mv="urn:schemas-microsoft-com:mac:vml" xmlns:p="http://schemas.openxmlformats.org/presentationml/2006/main" xmlns:c="http://schemas.openxmlformats.org/drawingml/2006/chart" xmlns:dgm="http://schemas.openxmlformats.org/drawingml/2006/diagram" xmlns:o="urn:schemas-microsoft-com:office:office" xmlns:v="urn:schemas-microsoft-com:vml" xmlns:pvml="urn:schemas-microsoft-com:office:powerpoint" xmlns:com="http://schemas.openxmlformats.org/drawingml/2006/compatibility" xmlns:p14="http://schemas.microsoft.com/office/powerpoint/2010/main" xmlns:p15="http://schemas.microsoft.com/office/powerpoint/2012/main" xmlns:ahyp="http://schemas.microsoft.com/office/drawing/2018/hyperlinkcolor">
+  <p:cSld>
+    <p:spTree>
+      <p:nvGrpSpPr>
+        <p:cNvPr id="300" name="Shape 300"/>
+        <p:cNvGrpSpPr/>
+        <p:nvPr/>
+      </p:nvGrpSpPr>
+      <p:grpSpPr>
+        <a:xfrm>
+          <a:off x="0" y="0"/>
+          <a:ext cx="0" cy="0"/>
+          <a:chOff x="0" y="0"/>
+          <a:chExt cx="0" cy="0"/>
+        </a:xfrm>
+      </p:grpSpPr>
+      <p:sp>
+        <p:nvSpPr>
+          <p:cNvPr id="301" name="Google Shape;301;p22"/>
+          <p:cNvSpPr txBox="1"/>
+          <p:nvPr>
+            <p:ph type="title"/>
+          </p:nvPr>
+        </p:nvSpPr>
+        <p:spPr>
+          <a:xfrm>
+            <a:off x="311700" y="445025"/>
+            <a:ext cx="8520600" cy="572700"/>
+          </a:xfrm>
+          <a:prstGeom prst="rect">
+            <a:avLst/>
+          </a:prstGeom>
+          <a:noFill/>
+          <a:ln>
+            <a:noFill/>
+          </a:ln>
+        </p:spPr>
+        <p:txBody>
+          <a:bodyPr anchorCtr="0" anchor="t" bIns="91425" lIns="91425" spcFirstLastPara="1" rIns="91425" wrap="square" tIns="91425">
+            <a:normAutofit fontScale="90000"/>
+          </a:bodyPr>
+          <a:lstStyle/>
+          <a:p>
+            <a:pPr indent="0" lvl="0" marL="0" rtl="0" algn="l">
+              <a:lnSpc>
+                <a:spcPct val="100000"/>
+              </a:lnSpc>
+              <a:spcBef>
+                <a:spcPts val="0"/>
+              </a:spcBef>
+              <a:spcAft>
+                <a:spcPts val="0"/>
+              </a:spcAft>
+              <a:buSzPct val="111111"/>
+              <a:buNone/>
+            </a:pPr>
+            <a:r>
+              <a:rPr lang="vi-VN"/>
+              <a:t>4 – d) Khối Dữ liệu và Khung nhìn Vật lý hóa</a:t>
+            </a:r>
+            <a:br>
+              <a:rPr lang="vi-VN"/>
+            </a:br>
+            <a:endParaRPr/>
+          </a:p>
+        </p:txBody>
+      </p:sp>
+      <p:sp>
+        <p:nvSpPr>
+          <p:cNvPr id="302" name="Google Shape;302;p22"/>
+          <p:cNvSpPr txBox="1"/>
+          <p:nvPr>
+            <p:ph idx="1" type="body"/>
+          </p:nvPr>
+        </p:nvSpPr>
+        <p:spPr>
+          <a:xfrm>
+            <a:off x="311700" y="1152475"/>
+            <a:ext cx="8520600" cy="3416400"/>
+          </a:xfrm>
+          <a:prstGeom prst="rect">
+            <a:avLst/>
+          </a:prstGeom>
+          <a:noFill/>
+          <a:ln>
+            <a:noFill/>
+          </a:ln>
+        </p:spPr>
         <p:txBody>
           <a:bodyPr anchorCtr="0" anchor="t" bIns="91425" lIns="91425" spcFirstLastPara="1" rIns="91425" wrap="square" tIns="91425">
             <a:normAutofit/>
@@ -17079,6 +18178,336 @@
               <a:buChar char="●"/>
             </a:pPr>
             <a:r>
+              <a:rPr lang="vi-VN"/>
+              <a:t>Đây là các kỹ thuật </a:t>
+            </a:r>
+            <a:r>
+              <a:rPr b="1" lang="vi-VN"/>
+              <a:t>tính toán trước (precompute)</a:t>
+            </a:r>
+            <a:r>
+              <a:rPr lang="vi-VN"/>
+              <a:t> các kết quả tổng hợp (ví dụ: tổng doanh số theo ngày và sản phẩm) để </a:t>
+            </a:r>
+            <a:r>
+              <a:rPr b="1" lang="vi-VN"/>
+              <a:t>tăng tốc các truy vấn </a:t>
+            </a:r>
+            <a:r>
+              <a:rPr lang="vi-VN"/>
+              <a:t>phân tích, thay vì tính toán trên dữ liệu thô (raw data) mỗi lần.</a:t>
+            </a:r>
+            <a:endParaRPr/>
+          </a:p>
+        </p:txBody>
+      </p:sp>
+      <p:sp>
+        <p:nvSpPr>
+          <p:cNvPr id="303" name="Google Shape;303;p22"/>
+          <p:cNvSpPr txBox="1"/>
+          <p:nvPr>
+            <p:ph idx="12" type="sldNum"/>
+          </p:nvPr>
+        </p:nvSpPr>
+        <p:spPr>
+          <a:xfrm>
+            <a:off x="8472458" y="4663217"/>
+            <a:ext cx="548700" cy="393600"/>
+          </a:xfrm>
+          <a:prstGeom prst="rect">
+            <a:avLst/>
+          </a:prstGeom>
+        </p:spPr>
+        <p:txBody>
+          <a:bodyPr anchorCtr="0" anchor="ctr" bIns="91425" lIns="91425" spcFirstLastPara="1" rIns="91425" wrap="square" tIns="91425">
+            <a:normAutofit/>
+          </a:bodyPr>
+          <a:lstStyle/>
+          <a:p>
+            <a:pPr indent="0" lvl="0" marL="0" rtl="0" algn="r">
+              <a:spcBef>
+                <a:spcPts val="0"/>
+              </a:spcBef>
+              <a:spcAft>
+                <a:spcPts val="0"/>
+              </a:spcAft>
+              <a:buClr>
+                <a:srgbClr val="000000"/>
+              </a:buClr>
+              <a:buSzPts val="1000"/>
+              <a:buFont typeface="Arial"/>
+              <a:buNone/>
+            </a:pPr>
+            <a:fld id="{00000000-1234-1234-1234-123412341234}" type="slidenum">
+              <a:rPr lang="vi-VN"/>
+              <a:t>‹#›</a:t>
+            </a:fld>
+            <a:endParaRPr/>
+          </a:p>
+        </p:txBody>
+      </p:sp>
+    </p:spTree>
+  </p:cSld>
+  <p:clrMapOvr>
+    <a:masterClrMapping/>
+  </p:clrMapOvr>
+</p:sld>
+</file>
+
+<file path=ppt/slides/slide35.xml><?xml version="1.0" encoding="utf-8"?>
+<p:sld xmlns:a="http://schemas.openxmlformats.org/drawingml/2006/main" xmlns:r="http://schemas.openxmlformats.org/officeDocument/2006/relationships" xmlns:mc="http://schemas.openxmlformats.org/markup-compatibility/2006" xmlns:mv="urn:schemas-microsoft-com:mac:vml" xmlns:p="http://schemas.openxmlformats.org/presentationml/2006/main" xmlns:c="http://schemas.openxmlformats.org/drawingml/2006/chart" xmlns:dgm="http://schemas.openxmlformats.org/drawingml/2006/diagram" xmlns:o="urn:schemas-microsoft-com:office:office" xmlns:v="urn:schemas-microsoft-com:vml" xmlns:pvml="urn:schemas-microsoft-com:office:powerpoint" xmlns:com="http://schemas.openxmlformats.org/drawingml/2006/compatibility" xmlns:p14="http://schemas.microsoft.com/office/powerpoint/2010/main" xmlns:p15="http://schemas.microsoft.com/office/powerpoint/2012/main" xmlns:ahyp="http://schemas.microsoft.com/office/drawing/2018/hyperlinkcolor">
+  <p:cSld>
+    <p:spTree>
+      <p:nvGrpSpPr>
+        <p:cNvPr id="307" name="Shape 307"/>
+        <p:cNvGrpSpPr/>
+        <p:nvPr/>
+      </p:nvGrpSpPr>
+      <p:grpSpPr>
+        <a:xfrm>
+          <a:off x="0" y="0"/>
+          <a:ext cx="0" cy="0"/>
+          <a:chOff x="0" y="0"/>
+          <a:chExt cx="0" cy="0"/>
+        </a:xfrm>
+      </p:grpSpPr>
+      <p:sp>
+        <p:nvSpPr>
+          <p:cNvPr id="308" name="Google Shape;308;p23"/>
+          <p:cNvSpPr txBox="1"/>
+          <p:nvPr>
+            <p:ph type="title"/>
+          </p:nvPr>
+        </p:nvSpPr>
+        <p:spPr>
+          <a:xfrm>
+            <a:off x="311700" y="445025"/>
+            <a:ext cx="8520600" cy="572700"/>
+          </a:xfrm>
+          <a:prstGeom prst="rect">
+            <a:avLst/>
+          </a:prstGeom>
+          <a:noFill/>
+          <a:ln>
+            <a:noFill/>
+          </a:ln>
+        </p:spPr>
+        <p:txBody>
+          <a:bodyPr anchorCtr="0" anchor="t" bIns="91425" lIns="91425" spcFirstLastPara="1" rIns="91425" wrap="square" tIns="91425">
+            <a:normAutofit fontScale="90000"/>
+          </a:bodyPr>
+          <a:lstStyle/>
+          <a:p>
+            <a:pPr indent="0" lvl="0" marL="0" rtl="0" algn="l">
+              <a:lnSpc>
+                <a:spcPct val="100000"/>
+              </a:lnSpc>
+              <a:spcBef>
+                <a:spcPts val="0"/>
+              </a:spcBef>
+              <a:spcAft>
+                <a:spcPts val="0"/>
+              </a:spcAft>
+              <a:buSzPct val="111111"/>
+              <a:buNone/>
+            </a:pPr>
+            <a:r>
+              <a:rPr lang="vi-VN"/>
+              <a:t>4 – d) Khối Dữ liệu và Khung nhìn Vật lý hóa</a:t>
+            </a:r>
+            <a:br>
+              <a:rPr lang="vi-VN"/>
+            </a:br>
+            <a:endParaRPr/>
+          </a:p>
+        </p:txBody>
+      </p:sp>
+      <p:pic>
+        <p:nvPicPr>
+          <p:cNvPr id="309" name="Google Shape;309;p23"/>
+          <p:cNvPicPr preferRelativeResize="0"/>
+          <p:nvPr/>
+        </p:nvPicPr>
+        <p:blipFill rotWithShape="1">
+          <a:blip r:embed="rId3">
+            <a:alphaModFix/>
+          </a:blip>
+          <a:srcRect b="0" l="0" r="0" t="0"/>
+          <a:stretch/>
+        </p:blipFill>
+        <p:spPr>
+          <a:xfrm>
+            <a:off x="1072957" y="1017725"/>
+            <a:ext cx="6998085" cy="3680750"/>
+          </a:xfrm>
+          <a:prstGeom prst="rect">
+            <a:avLst/>
+          </a:prstGeom>
+          <a:noFill/>
+          <a:ln>
+            <a:noFill/>
+          </a:ln>
+        </p:spPr>
+      </p:pic>
+      <p:sp>
+        <p:nvSpPr>
+          <p:cNvPr id="310" name="Google Shape;310;p23"/>
+          <p:cNvSpPr txBox="1"/>
+          <p:nvPr>
+            <p:ph idx="12" type="sldNum"/>
+          </p:nvPr>
+        </p:nvSpPr>
+        <p:spPr>
+          <a:xfrm>
+            <a:off x="8472458" y="4663217"/>
+            <a:ext cx="548700" cy="393600"/>
+          </a:xfrm>
+          <a:prstGeom prst="rect">
+            <a:avLst/>
+          </a:prstGeom>
+        </p:spPr>
+        <p:txBody>
+          <a:bodyPr anchorCtr="0" anchor="ctr" bIns="91425" lIns="91425" spcFirstLastPara="1" rIns="91425" wrap="square" tIns="91425">
+            <a:normAutofit/>
+          </a:bodyPr>
+          <a:lstStyle/>
+          <a:p>
+            <a:pPr indent="0" lvl="0" marL="0" rtl="0" algn="r">
+              <a:spcBef>
+                <a:spcPts val="0"/>
+              </a:spcBef>
+              <a:spcAft>
+                <a:spcPts val="0"/>
+              </a:spcAft>
+              <a:buClr>
+                <a:srgbClr val="000000"/>
+              </a:buClr>
+              <a:buSzPts val="1000"/>
+              <a:buFont typeface="Arial"/>
+              <a:buNone/>
+            </a:pPr>
+            <a:fld id="{00000000-1234-1234-1234-123412341234}" type="slidenum">
+              <a:rPr lang="vi-VN"/>
+              <a:t>‹#›</a:t>
+            </a:fld>
+            <a:endParaRPr/>
+          </a:p>
+        </p:txBody>
+      </p:sp>
+    </p:spTree>
+  </p:cSld>
+  <p:clrMapOvr>
+    <a:masterClrMapping/>
+  </p:clrMapOvr>
+</p:sld>
+</file>
+
+<file path=ppt/slides/slide36.xml><?xml version="1.0" encoding="utf-8"?>
+<p:sld xmlns:a="http://schemas.openxmlformats.org/drawingml/2006/main" xmlns:r="http://schemas.openxmlformats.org/officeDocument/2006/relationships" xmlns:mc="http://schemas.openxmlformats.org/markup-compatibility/2006" xmlns:mv="urn:schemas-microsoft-com:mac:vml" xmlns:p="http://schemas.openxmlformats.org/presentationml/2006/main" xmlns:c="http://schemas.openxmlformats.org/drawingml/2006/chart" xmlns:dgm="http://schemas.openxmlformats.org/drawingml/2006/diagram" xmlns:o="urn:schemas-microsoft-com:office:office" xmlns:v="urn:schemas-microsoft-com:vml" xmlns:pvml="urn:schemas-microsoft-com:office:powerpoint" xmlns:com="http://schemas.openxmlformats.org/drawingml/2006/compatibility" xmlns:p14="http://schemas.microsoft.com/office/powerpoint/2010/main" xmlns:p15="http://schemas.microsoft.com/office/powerpoint/2012/main" xmlns:ahyp="http://schemas.microsoft.com/office/drawing/2018/hyperlinkcolor">
+  <p:cSld>
+    <p:spTree>
+      <p:nvGrpSpPr>
+        <p:cNvPr id="314" name="Shape 314"/>
+        <p:cNvGrpSpPr/>
+        <p:nvPr/>
+      </p:nvGrpSpPr>
+      <p:grpSpPr>
+        <a:xfrm>
+          <a:off x="0" y="0"/>
+          <a:ext cx="0" cy="0"/>
+          <a:chOff x="0" y="0"/>
+          <a:chExt cx="0" cy="0"/>
+        </a:xfrm>
+      </p:grpSpPr>
+      <p:sp>
+        <p:nvSpPr>
+          <p:cNvPr id="315" name="Google Shape;315;p24"/>
+          <p:cNvSpPr txBox="1"/>
+          <p:nvPr>
+            <p:ph type="title"/>
+          </p:nvPr>
+        </p:nvSpPr>
+        <p:spPr>
+          <a:xfrm>
+            <a:off x="311700" y="445025"/>
+            <a:ext cx="8520600" cy="572700"/>
+          </a:xfrm>
+          <a:prstGeom prst="rect">
+            <a:avLst/>
+          </a:prstGeom>
+          <a:noFill/>
+          <a:ln>
+            <a:noFill/>
+          </a:ln>
+        </p:spPr>
+        <p:txBody>
+          <a:bodyPr anchorCtr="0" anchor="t" bIns="91425" lIns="91425" spcFirstLastPara="1" rIns="91425" wrap="square" tIns="91425">
+            <a:normAutofit fontScale="90000"/>
+          </a:bodyPr>
+          <a:lstStyle/>
+          <a:p>
+            <a:pPr indent="0" lvl="0" marL="0" rtl="0" algn="l">
+              <a:lnSpc>
+                <a:spcPct val="100000"/>
+              </a:lnSpc>
+              <a:spcBef>
+                <a:spcPts val="0"/>
+              </a:spcBef>
+              <a:spcAft>
+                <a:spcPts val="0"/>
+              </a:spcAft>
+              <a:buSzPct val="111111"/>
+              <a:buNone/>
+            </a:pPr>
+            <a:r>
+              <a:rPr lang="vi-VN"/>
+              <a:t>Tham khảo</a:t>
+            </a:r>
+            <a:endParaRPr/>
+          </a:p>
+        </p:txBody>
+      </p:sp>
+      <p:sp>
+        <p:nvSpPr>
+          <p:cNvPr id="316" name="Google Shape;316;p24"/>
+          <p:cNvSpPr txBox="1"/>
+          <p:nvPr>
+            <p:ph idx="1" type="body"/>
+          </p:nvPr>
+        </p:nvSpPr>
+        <p:spPr>
+          <a:xfrm>
+            <a:off x="311700" y="1152475"/>
+            <a:ext cx="8520600" cy="3416400"/>
+          </a:xfrm>
+          <a:prstGeom prst="rect">
+            <a:avLst/>
+          </a:prstGeom>
+          <a:noFill/>
+          <a:ln>
+            <a:noFill/>
+          </a:ln>
+        </p:spPr>
+        <p:txBody>
+          <a:bodyPr anchorCtr="0" anchor="t" bIns="91425" lIns="91425" spcFirstLastPara="1" rIns="91425" wrap="square" tIns="91425">
+            <a:normAutofit/>
+          </a:bodyPr>
+          <a:lstStyle/>
+          <a:p>
+            <a:pPr indent="-342900" lvl="0" marL="457200" rtl="0" algn="l">
+              <a:lnSpc>
+                <a:spcPct val="115000"/>
+              </a:lnSpc>
+              <a:spcBef>
+                <a:spcPts val="0"/>
+              </a:spcBef>
+              <a:spcAft>
+                <a:spcPts val="0"/>
+              </a:spcAft>
+              <a:buSzPts val="1800"/>
+              <a:buChar char="●"/>
+            </a:pPr>
+            <a:r>
               <a:rPr b="1" lang="vi-VN"/>
               <a:t>Chapter 3 - Storage &amp; Retrieval - Designing Data Intensive applications book </a:t>
             </a:r>
@@ -17159,7 +18588,7 @@
       </p:sp>
       <p:sp>
         <p:nvSpPr>
-          <p:cNvPr id="282" name="Google Shape;282;p24"/>
+          <p:cNvPr id="317" name="Google Shape;317;p24"/>
           <p:cNvSpPr txBox="1"/>
           <p:nvPr>
             <p:ph idx="12" type="sldNum"/>

</xml_diff>